<commit_message>
feat: enrich finance app visuals and AI service
</commit_message>
<xml_diff>
--- a/金融客户定制App产品方案-演示版.pptx
+++ b/金融客户定制App产品方案-演示版.pptx
@@ -20,6 +20,7 @@
     <p:sldId id="268" r:id="rId19"/>
     <p:sldId id="269" r:id="rId20"/>
     <p:sldId id="270" r:id="rId21"/>
+    <p:sldId id="271" r:id="rId22"/>
   </p:sldIdLst>
   <p:sldSz cx="12191695" cy="6858000" type="screen4x3"/>
   <p:notesSz cx="6858000" cy="9144000"/>
@@ -6785,7 +6786,7 @@
                 <a:ea typeface="Arial Unicode MS"/>
                 <a:cs typeface="Arial Unicode MS"/>
               </a:rPr>
-              <a:t>品牌、后台与合规能力</a:t>
+              <a:t>AI 助手：接入客户 Agent，或定制金融服务 Agent</a:t>
             </a:r>
           </a:p>
         </p:txBody>
@@ -6829,14 +6830,51 @@
       </p:sp>
       <p:sp>
         <p:nvSpPr>
-          <p:cNvPr id="8" name="Rounded Rectangle 7"/>
+          <p:cNvPr id="8" name="TextBox 7"/>
+          <p:cNvSpPr txBox="1"/>
+          <p:nvPr/>
+        </p:nvSpPr>
+        <p:spPr>
+          <a:xfrm>
+            <a:off x="777240" y="1298448"/>
+            <a:ext cx="9601200" cy="320040"/>
+          </a:xfrm>
+          <a:prstGeom prst="rect">
+            <a:avLst/>
+          </a:prstGeom>
+          <a:noFill/>
+        </p:spPr>
+        <p:txBody>
+          <a:bodyPr wrap="square" lIns="0" rIns="0" tIns="0" bIns="0">
+            <a:spAutoFit/>
+          </a:bodyPr>
+          <a:lstStyle/>
+          <a:p>
+            <a:pPr algn="l"/>
+            <a:r>
+              <a:rPr sz="1500" b="1">
+                <a:solidFill>
+                  <a:srgbClr val="071B43"/>
+                </a:solidFill>
+                <a:latin typeface="Arial Unicode MS"/>
+                <a:ea typeface="Arial Unicode MS"/>
+                <a:cs typeface="Arial Unicode MS"/>
+              </a:rPr>
+              <a:t>把客户已经拥有的内容、知识库和服务流程，转成 App 内可用的服务入口。</a:t>
+            </a:r>
+          </a:p>
+        </p:txBody>
+      </p:sp>
+      <p:sp>
+        <p:nvSpPr>
+          <p:cNvPr id="9" name="Rounded Rectangle 8"/>
           <p:cNvSpPr/>
           <p:nvPr/>
         </p:nvSpPr>
         <p:spPr>
           <a:xfrm>
-            <a:off x="777240" y="1325880"/>
-            <a:ext cx="4846320" cy="896112"/>
+            <a:off x="777240" y="1901952"/>
+            <a:ext cx="4800600" cy="1353312"/>
           </a:xfrm>
           <a:prstGeom prst="roundRect">
             <a:avLst/>
@@ -6874,14 +6912,14 @@
       </p:sp>
       <p:sp>
         <p:nvSpPr>
-          <p:cNvPr id="9" name="Rounded Rectangle 8"/>
+          <p:cNvPr id="10" name="Rounded Rectangle 9"/>
           <p:cNvSpPr/>
           <p:nvPr/>
         </p:nvSpPr>
         <p:spPr>
           <a:xfrm>
-            <a:off x="987552" y="1545336"/>
-            <a:ext cx="128016" cy="457200"/>
+            <a:off x="777240" y="1901952"/>
+            <a:ext cx="4800600" cy="118872"/>
           </a:xfrm>
           <a:prstGeom prst="roundRect">
             <a:avLst/>
@@ -6917,29 +6955,29 @@
       </p:sp>
       <p:sp>
         <p:nvSpPr>
-          <p:cNvPr id="10" name="TextBox 9"/>
-          <p:cNvSpPr txBox="1"/>
-          <p:nvPr/>
-        </p:nvSpPr>
-        <p:spPr>
-          <a:xfrm>
-            <a:off x="1417320" y="1508760"/>
-            <a:ext cx="1280160" cy="210312"/>
-          </a:xfrm>
-          <a:prstGeom prst="rect">
-            <a:avLst/>
-          </a:prstGeom>
-          <a:noFill/>
-        </p:spPr>
-        <p:txBody>
-          <a:bodyPr wrap="square" lIns="0" rIns="0" tIns="0" bIns="0">
-            <a:spAutoFit/>
-          </a:bodyPr>
-          <a:lstStyle/>
-          <a:p>
-            <a:pPr algn="l"/>
-            <a:r>
-              <a:rPr sz="1400" b="1">
+          <p:cNvPr id="11" name="TextBox 10"/>
+          <p:cNvSpPr txBox="1"/>
+          <p:nvPr/>
+        </p:nvSpPr>
+        <p:spPr>
+          <a:xfrm>
+            <a:off x="1005840" y="2176272"/>
+            <a:ext cx="4160520" cy="228600"/>
+          </a:xfrm>
+          <a:prstGeom prst="rect">
+            <a:avLst/>
+          </a:prstGeom>
+          <a:noFill/>
+        </p:spPr>
+        <p:txBody>
+          <a:bodyPr wrap="square" lIns="0" rIns="0" tIns="0" bIns="0">
+            <a:spAutoFit/>
+          </a:bodyPr>
+          <a:lstStyle/>
+          <a:p>
+            <a:pPr algn="l"/>
+            <a:r>
+              <a:rPr sz="1500" b="1">
                 <a:solidFill>
                   <a:srgbClr val="071B43"/>
                 </a:solidFill>
@@ -6947,21 +6985,21 @@
                 <a:ea typeface="Arial Unicode MS"/>
                 <a:cs typeface="Arial Unicode MS"/>
               </a:rPr>
-              <a:t>品牌能力</a:t>
-            </a:r>
-          </a:p>
-        </p:txBody>
-      </p:sp>
-      <p:sp>
-        <p:nvSpPr>
-          <p:cNvPr id="11" name="TextBox 10"/>
-          <p:cNvSpPr txBox="1"/>
-          <p:nvPr/>
-        </p:nvSpPr>
-        <p:spPr>
-          <a:xfrm>
-            <a:off x="2788920" y="1508760"/>
-            <a:ext cx="2468880" cy="384048"/>
+              <a:t>接入客户现有 Agent</a:t>
+            </a:r>
+          </a:p>
+        </p:txBody>
+      </p:sp>
+      <p:sp>
+        <p:nvSpPr>
+          <p:cNvPr id="12" name="TextBox 11"/>
+          <p:cNvSpPr txBox="1"/>
+          <p:nvPr/>
+        </p:nvSpPr>
+        <p:spPr>
+          <a:xfrm>
+            <a:off x="1005840" y="2560320"/>
+            <a:ext cx="4160520" cy="457200"/>
           </a:xfrm>
           <a:prstGeom prst="rect">
             <a:avLst/>
@@ -6984,21 +7022,21 @@
                 <a:ea typeface="Arial Unicode MS"/>
                 <a:cs typeface="Arial Unicode MS"/>
               </a:rPr>
-              <a:t>Logo、主题色、首页 Banner、Tab 和页面风格可定制</a:t>
-            </a:r>
-          </a:p>
-        </p:txBody>
-      </p:sp>
-      <p:sp>
-        <p:nvSpPr>
-          <p:cNvPr id="12" name="Rounded Rectangle 11"/>
+              <a:t>复用客户知识库、Agent 编排与权限体系；App 提供品牌化入口、用户身份和服务上下文。</a:t>
+            </a:r>
+          </a:p>
+        </p:txBody>
+      </p:sp>
+      <p:sp>
+        <p:nvSpPr>
+          <p:cNvPr id="13" name="Rounded Rectangle 12"/>
           <p:cNvSpPr/>
           <p:nvPr/>
         </p:nvSpPr>
         <p:spPr>
           <a:xfrm>
-            <a:off x="777240" y="2313432"/>
-            <a:ext cx="4846320" cy="896112"/>
+            <a:off x="6126479" y="1901952"/>
+            <a:ext cx="4800600" cy="1353312"/>
           </a:xfrm>
           <a:prstGeom prst="roundRect">
             <a:avLst/>
@@ -7036,20 +7074,20 @@
       </p:sp>
       <p:sp>
         <p:nvSpPr>
-          <p:cNvPr id="13" name="Rounded Rectangle 12"/>
+          <p:cNvPr id="14" name="Rounded Rectangle 13"/>
           <p:cNvSpPr/>
           <p:nvPr/>
         </p:nvSpPr>
         <p:spPr>
           <a:xfrm>
-            <a:off x="987552" y="2532888"/>
-            <a:ext cx="128016" cy="457200"/>
+            <a:off x="6126479" y="1901952"/>
+            <a:ext cx="4800600" cy="118872"/>
           </a:xfrm>
           <a:prstGeom prst="roundRect">
             <a:avLst/>
           </a:prstGeom>
           <a:solidFill>
-            <a:srgbClr val="D7AA4B"/>
+            <a:srgbClr val="26977D"/>
           </a:solidFill>
           <a:ln>
             <a:noFill/>
@@ -7079,29 +7117,29 @@
       </p:sp>
       <p:sp>
         <p:nvSpPr>
-          <p:cNvPr id="14" name="TextBox 13"/>
-          <p:cNvSpPr txBox="1"/>
-          <p:nvPr/>
-        </p:nvSpPr>
-        <p:spPr>
-          <a:xfrm>
-            <a:off x="1417320" y="2496312"/>
-            <a:ext cx="1280160" cy="210312"/>
-          </a:xfrm>
-          <a:prstGeom prst="rect">
-            <a:avLst/>
-          </a:prstGeom>
-          <a:noFill/>
-        </p:spPr>
-        <p:txBody>
-          <a:bodyPr wrap="square" lIns="0" rIns="0" tIns="0" bIns="0">
-            <a:spAutoFit/>
-          </a:bodyPr>
-          <a:lstStyle/>
-          <a:p>
-            <a:pPr algn="l"/>
-            <a:r>
-              <a:rPr sz="1400" b="1">
+          <p:cNvPr id="15" name="TextBox 14"/>
+          <p:cNvSpPr txBox="1"/>
+          <p:nvPr/>
+        </p:nvSpPr>
+        <p:spPr>
+          <a:xfrm>
+            <a:off x="6355079" y="2176272"/>
+            <a:ext cx="4160520" cy="228600"/>
+          </a:xfrm>
+          <a:prstGeom prst="rect">
+            <a:avLst/>
+          </a:prstGeom>
+          <a:noFill/>
+        </p:spPr>
+        <p:txBody>
+          <a:bodyPr wrap="square" lIns="0" rIns="0" tIns="0" bIns="0">
+            <a:spAutoFit/>
+          </a:bodyPr>
+          <a:lstStyle/>
+          <a:p>
+            <a:pPr algn="l"/>
+            <a:r>
+              <a:rPr sz="1500" b="1">
                 <a:solidFill>
                   <a:srgbClr val="071B43"/>
                 </a:solidFill>
@@ -7109,21 +7147,21 @@
                 <a:ea typeface="Arial Unicode MS"/>
                 <a:cs typeface="Arial Unicode MS"/>
               </a:rPr>
-              <a:t>后台能力</a:t>
-            </a:r>
-          </a:p>
-        </p:txBody>
-      </p:sp>
-      <p:sp>
-        <p:nvSpPr>
-          <p:cNvPr id="15" name="TextBox 14"/>
-          <p:cNvSpPr txBox="1"/>
-          <p:nvPr/>
-        </p:nvSpPr>
-        <p:spPr>
-          <a:xfrm>
-            <a:off x="2788920" y="2496312"/>
-            <a:ext cx="2468880" cy="384048"/>
+              <a:t>定制金融服务 Agent</a:t>
+            </a:r>
+          </a:p>
+        </p:txBody>
+      </p:sp>
+      <p:sp>
+        <p:nvSpPr>
+          <p:cNvPr id="16" name="TextBox 15"/>
+          <p:cNvSpPr txBox="1"/>
+          <p:nvPr/>
+        </p:nvSpPr>
+        <p:spPr>
+          <a:xfrm>
+            <a:off x="6355079" y="2560320"/>
+            <a:ext cx="4160520" cy="457200"/>
           </a:xfrm>
           <a:prstGeom prst="rect">
             <a:avLst/>
@@ -7146,21 +7184,58 @@
                 <a:ea typeface="Arial Unicode MS"/>
                 <a:cs typeface="Arial Unicode MS"/>
               </a:rPr>
-              <a:t>内容、课程、圈子、直播、消息和用户标签统一运营</a:t>
-            </a:r>
-          </a:p>
-        </p:txBody>
-      </p:sp>
-      <p:sp>
-        <p:nvSpPr>
-          <p:cNvPr id="16" name="Rounded Rectangle 15"/>
+              <a:t>围绕课程、直播回放、圈子内容、FAQ 和服务 SOP 定制内容检索、学习辅助与服务分流能力。</a:t>
+            </a:r>
+          </a:p>
+        </p:txBody>
+      </p:sp>
+      <p:sp>
+        <p:nvSpPr>
+          <p:cNvPr id="17" name="TextBox 16"/>
+          <p:cNvSpPr txBox="1"/>
+          <p:nvPr/>
+        </p:nvSpPr>
+        <p:spPr>
+          <a:xfrm>
+            <a:off x="777240" y="3822191"/>
+            <a:ext cx="2743200" cy="228600"/>
+          </a:xfrm>
+          <a:prstGeom prst="rect">
+            <a:avLst/>
+          </a:prstGeom>
+          <a:noFill/>
+        </p:spPr>
+        <p:txBody>
+          <a:bodyPr wrap="square" lIns="0" rIns="0" tIns="0" bIns="0">
+            <a:spAutoFit/>
+          </a:bodyPr>
+          <a:lstStyle/>
+          <a:p>
+            <a:pPr algn="l"/>
+            <a:r>
+              <a:rPr sz="1500" b="1">
+                <a:solidFill>
+                  <a:srgbClr val="071B43"/>
+                </a:solidFill>
+                <a:latin typeface="Arial Unicode MS"/>
+                <a:ea typeface="Arial Unicode MS"/>
+                <a:cs typeface="Arial Unicode MS"/>
+              </a:rPr>
+              <a:t>Demo 中的服务体验</a:t>
+            </a:r>
+          </a:p>
+        </p:txBody>
+      </p:sp>
+      <p:sp>
+        <p:nvSpPr>
+          <p:cNvPr id="18" name="Rounded Rectangle 17"/>
           <p:cNvSpPr/>
           <p:nvPr/>
         </p:nvSpPr>
         <p:spPr>
           <a:xfrm>
-            <a:off x="777240" y="3300984"/>
-            <a:ext cx="4846320" cy="896112"/>
+            <a:off x="777240" y="4251960"/>
+            <a:ext cx="3017520" cy="1051560"/>
           </a:xfrm>
           <a:prstGeom prst="roundRect">
             <a:avLst/>
@@ -7198,20 +7273,20 @@
       </p:sp>
       <p:sp>
         <p:nvSpPr>
-          <p:cNvPr id="17" name="Rounded Rectangle 16"/>
+          <p:cNvPr id="19" name="Rounded Rectangle 18"/>
           <p:cNvSpPr/>
           <p:nvPr/>
         </p:nvSpPr>
         <p:spPr>
           <a:xfrm>
-            <a:off x="987552" y="3520440"/>
-            <a:ext cx="128016" cy="457200"/>
+            <a:off x="960120" y="4480560"/>
+            <a:ext cx="329184" cy="329184"/>
           </a:xfrm>
           <a:prstGeom prst="roundRect">
             <a:avLst/>
           </a:prstGeom>
           <a:solidFill>
-            <a:srgbClr val="26977D"/>
+            <a:srgbClr val="1C53AE"/>
           </a:solidFill>
           <a:ln>
             <a:noFill/>
@@ -7241,29 +7316,29 @@
       </p:sp>
       <p:sp>
         <p:nvSpPr>
-          <p:cNvPr id="18" name="TextBox 17"/>
-          <p:cNvSpPr txBox="1"/>
-          <p:nvPr/>
-        </p:nvSpPr>
-        <p:spPr>
-          <a:xfrm>
-            <a:off x="1417320" y="3483864"/>
-            <a:ext cx="1280160" cy="210312"/>
-          </a:xfrm>
-          <a:prstGeom prst="rect">
-            <a:avLst/>
-          </a:prstGeom>
-          <a:noFill/>
-        </p:spPr>
-        <p:txBody>
-          <a:bodyPr wrap="square" lIns="0" rIns="0" tIns="0" bIns="0">
-            <a:spAutoFit/>
-          </a:bodyPr>
-          <a:lstStyle/>
-          <a:p>
-            <a:pPr algn="l"/>
-            <a:r>
-              <a:rPr sz="1400" b="1">
+          <p:cNvPr id="20" name="TextBox 19"/>
+          <p:cNvSpPr txBox="1"/>
+          <p:nvPr/>
+        </p:nvSpPr>
+        <p:spPr>
+          <a:xfrm>
+            <a:off x="1435607" y="4434840"/>
+            <a:ext cx="2057400" cy="201168"/>
+          </a:xfrm>
+          <a:prstGeom prst="rect">
+            <a:avLst/>
+          </a:prstGeom>
+          <a:noFill/>
+        </p:spPr>
+        <p:txBody>
+          <a:bodyPr wrap="square" lIns="0" rIns="0" tIns="0" bIns="0">
+            <a:spAutoFit/>
+          </a:bodyPr>
+          <a:lstStyle/>
+          <a:p>
+            <a:pPr algn="l"/>
+            <a:r>
+              <a:rPr sz="1200" b="1">
                 <a:solidFill>
                   <a:srgbClr val="071B43"/>
                 </a:solidFill>
@@ -7271,36 +7346,36 @@
                 <a:ea typeface="Arial Unicode MS"/>
                 <a:cs typeface="Arial Unicode MS"/>
               </a:rPr>
-              <a:t>定制开发</a:t>
-            </a:r>
-          </a:p>
-        </p:txBody>
-      </p:sp>
-      <p:sp>
-        <p:nvSpPr>
-          <p:cNvPr id="19" name="TextBox 18"/>
-          <p:cNvSpPr txBox="1"/>
-          <p:nvPr/>
-        </p:nvSpPr>
-        <p:spPr>
-          <a:xfrm>
-            <a:off x="2788920" y="3483864"/>
-            <a:ext cx="2468880" cy="384048"/>
-          </a:xfrm>
-          <a:prstGeom prst="rect">
-            <a:avLst/>
-          </a:prstGeom>
-          <a:noFill/>
-        </p:spPr>
-        <p:txBody>
-          <a:bodyPr wrap="square" lIns="0" rIns="0" tIns="0" bIns="0">
-            <a:spAutoFit/>
-          </a:bodyPr>
-          <a:lstStyle/>
-          <a:p>
-            <a:pPr algn="l"/>
-            <a:r>
-              <a:rPr sz="1000" b="0">
+              <a:t>内容检索与总结</a:t>
+            </a:r>
+          </a:p>
+        </p:txBody>
+      </p:sp>
+      <p:sp>
+        <p:nvSpPr>
+          <p:cNvPr id="21" name="TextBox 20"/>
+          <p:cNvSpPr txBox="1"/>
+          <p:nvPr/>
+        </p:nvSpPr>
+        <p:spPr>
+          <a:xfrm>
+            <a:off x="960120" y="4919472"/>
+            <a:ext cx="2560320" cy="256032"/>
+          </a:xfrm>
+          <a:prstGeom prst="rect">
+            <a:avLst/>
+          </a:prstGeom>
+          <a:noFill/>
+        </p:spPr>
+        <p:txBody>
+          <a:bodyPr wrap="square" lIns="0" rIns="0" tIns="0" bIns="0">
+            <a:spAutoFit/>
+          </a:bodyPr>
+          <a:lstStyle/>
+          <a:p>
+            <a:pPr algn="l"/>
+            <a:r>
+              <a:rPr sz="900" b="0">
                 <a:solidFill>
                   <a:srgbClr val="68748B"/>
                 </a:solidFill>
@@ -7308,21 +7383,21 @@
                 <a:ea typeface="Arial Unicode MS"/>
                 <a:cs typeface="Arial Unicode MS"/>
               </a:rPr>
-              <a:t>根据客户业务流程，提供页面、接口、数据和运营能力的定制开发</a:t>
-            </a:r>
-          </a:p>
-        </p:txBody>
-      </p:sp>
-      <p:sp>
-        <p:nvSpPr>
-          <p:cNvPr id="20" name="Rounded Rectangle 19"/>
+              <a:t>定位课程、直播、圈子和已授权知识内容</a:t>
+            </a:r>
+          </a:p>
+        </p:txBody>
+      </p:sp>
+      <p:sp>
+        <p:nvSpPr>
+          <p:cNvPr id="22" name="Rounded Rectangle 21"/>
           <p:cNvSpPr/>
           <p:nvPr/>
         </p:nvSpPr>
         <p:spPr>
           <a:xfrm>
-            <a:off x="777240" y="4288536"/>
-            <a:ext cx="4846320" cy="896112"/>
+            <a:off x="4206240" y="4251960"/>
+            <a:ext cx="3017520" cy="1051560"/>
           </a:xfrm>
           <a:prstGeom prst="roundRect">
             <a:avLst/>
@@ -7360,20 +7435,20 @@
       </p:sp>
       <p:sp>
         <p:nvSpPr>
-          <p:cNvPr id="21" name="Rounded Rectangle 20"/>
+          <p:cNvPr id="23" name="Rounded Rectangle 22"/>
           <p:cNvSpPr/>
           <p:nvPr/>
         </p:nvSpPr>
         <p:spPr>
           <a:xfrm>
-            <a:off x="987552" y="4507992"/>
-            <a:ext cx="128016" cy="457200"/>
+            <a:off x="4389120" y="4480560"/>
+            <a:ext cx="329184" cy="329184"/>
           </a:xfrm>
           <a:prstGeom prst="roundRect">
             <a:avLst/>
           </a:prstGeom>
           <a:solidFill>
-            <a:srgbClr val="BE4E5B"/>
+            <a:srgbClr val="D7AA4B"/>
           </a:solidFill>
           <a:ln>
             <a:noFill/>
@@ -7403,29 +7478,29 @@
       </p:sp>
       <p:sp>
         <p:nvSpPr>
-          <p:cNvPr id="22" name="TextBox 21"/>
-          <p:cNvSpPr txBox="1"/>
-          <p:nvPr/>
-        </p:nvSpPr>
-        <p:spPr>
-          <a:xfrm>
-            <a:off x="1417320" y="4471416"/>
-            <a:ext cx="1280160" cy="210312"/>
-          </a:xfrm>
-          <a:prstGeom prst="rect">
-            <a:avLst/>
-          </a:prstGeom>
-          <a:noFill/>
-        </p:spPr>
-        <p:txBody>
-          <a:bodyPr wrap="square" lIns="0" rIns="0" tIns="0" bIns="0">
-            <a:spAutoFit/>
-          </a:bodyPr>
-          <a:lstStyle/>
-          <a:p>
-            <a:pPr algn="l"/>
-            <a:r>
-              <a:rPr sz="1400" b="1">
+          <p:cNvPr id="24" name="TextBox 23"/>
+          <p:cNvSpPr txBox="1"/>
+          <p:nvPr/>
+        </p:nvSpPr>
+        <p:spPr>
+          <a:xfrm>
+            <a:off x="4864607" y="4434840"/>
+            <a:ext cx="2057400" cy="201168"/>
+          </a:xfrm>
+          <a:prstGeom prst="rect">
+            <a:avLst/>
+          </a:prstGeom>
+          <a:noFill/>
+        </p:spPr>
+        <p:txBody>
+          <a:bodyPr wrap="square" lIns="0" rIns="0" tIns="0" bIns="0">
+            <a:spAutoFit/>
+          </a:bodyPr>
+          <a:lstStyle/>
+          <a:p>
+            <a:pPr algn="l"/>
+            <a:r>
+              <a:rPr sz="1200" b="1">
                 <a:solidFill>
                   <a:srgbClr val="071B43"/>
                 </a:solidFill>
@@ -7433,36 +7508,36 @@
                 <a:ea typeface="Arial Unicode MS"/>
                 <a:cs typeface="Arial Unicode MS"/>
               </a:rPr>
-              <a:t>合规能力</a:t>
-            </a:r>
-          </a:p>
-        </p:txBody>
-      </p:sp>
-      <p:sp>
-        <p:nvSpPr>
-          <p:cNvPr id="23" name="TextBox 22"/>
-          <p:cNvSpPr txBox="1"/>
-          <p:nvPr/>
-        </p:nvSpPr>
-        <p:spPr>
-          <a:xfrm>
-            <a:off x="2788920" y="4471416"/>
-            <a:ext cx="2468880" cy="384048"/>
-          </a:xfrm>
-          <a:prstGeom prst="rect">
-            <a:avLst/>
-          </a:prstGeom>
-          <a:noFill/>
-        </p:spPr>
-        <p:txBody>
-          <a:bodyPr wrap="square" lIns="0" rIns="0" tIns="0" bIns="0">
-            <a:spAutoFit/>
-          </a:bodyPr>
-          <a:lstStyle/>
-          <a:p>
-            <a:pPr algn="l"/>
-            <a:r>
-              <a:rPr sz="1000" b="0">
+              <a:t>课程与直播辅助</a:t>
+            </a:r>
+          </a:p>
+        </p:txBody>
+      </p:sp>
+      <p:sp>
+        <p:nvSpPr>
+          <p:cNvPr id="25" name="TextBox 24"/>
+          <p:cNvSpPr txBox="1"/>
+          <p:nvPr/>
+        </p:nvSpPr>
+        <p:spPr>
+          <a:xfrm>
+            <a:off x="4389120" y="4919472"/>
+            <a:ext cx="2560320" cy="256032"/>
+          </a:xfrm>
+          <a:prstGeom prst="rect">
+            <a:avLst/>
+          </a:prstGeom>
+          <a:noFill/>
+        </p:spPr>
+        <p:txBody>
+          <a:bodyPr wrap="square" lIns="0" rIns="0" tIns="0" bIns="0">
+            <a:spAutoFit/>
+          </a:bodyPr>
+          <a:lstStyle/>
+          <a:p>
+            <a:pPr algn="l"/>
+            <a:r>
+              <a:rPr sz="900" b="0">
                 <a:solidFill>
                   <a:srgbClr val="68748B"/>
                 </a:solidFill>
@@ -7470,323 +7545,21 @@
                 <a:ea typeface="Arial Unicode MS"/>
                 <a:cs typeface="Arial Unicode MS"/>
               </a:rPr>
-              <a:t>隐私协议、风险提示、执业信息、权限和内容审核可配置</a:t>
-            </a:r>
-          </a:p>
-        </p:txBody>
-      </p:sp>
-      <p:sp>
-        <p:nvSpPr>
-          <p:cNvPr id="24" name="Rounded Rectangle 23"/>
+              <a:t>梳理重点、关联资料、继续学习与任务引导</a:t>
+            </a:r>
+          </a:p>
+        </p:txBody>
+      </p:sp>
+      <p:sp>
+        <p:nvSpPr>
+          <p:cNvPr id="26" name="Rounded Rectangle 25"/>
           <p:cNvSpPr/>
           <p:nvPr/>
         </p:nvSpPr>
         <p:spPr>
           <a:xfrm>
-            <a:off x="6400800" y="1417320"/>
-            <a:ext cx="4160520" cy="4114800"/>
-          </a:xfrm>
-          <a:prstGeom prst="roundRect">
-            <a:avLst/>
-          </a:prstGeom>
-          <a:solidFill>
-            <a:srgbClr val="071B43"/>
-          </a:solidFill>
-          <a:ln>
-            <a:noFill/>
-          </a:ln>
-        </p:spPr>
-        <p:style>
-          <a:lnRef idx="1">
-            <a:schemeClr val="accent1"/>
-          </a:lnRef>
-          <a:fillRef idx="3">
-            <a:schemeClr val="accent1"/>
-          </a:fillRef>
-          <a:effectRef idx="2">
-            <a:schemeClr val="accent1"/>
-          </a:effectRef>
-          <a:fontRef idx="minor">
-            <a:schemeClr val="lt1"/>
-          </a:fontRef>
-        </p:style>
-        <p:txBody>
-          <a:bodyPr rtlCol="0" anchor="ctr"/>
-          <a:lstStyle/>
-          <a:p>
-            <a:pPr algn="ctr"/>
-          </a:p>
-        </p:txBody>
-      </p:sp>
-      <p:sp>
-        <p:nvSpPr>
-          <p:cNvPr id="25" name="TextBox 24"/>
-          <p:cNvSpPr txBox="1"/>
-          <p:nvPr/>
-        </p:nvSpPr>
-        <p:spPr>
-          <a:xfrm>
-            <a:off x="6995160" y="1828800"/>
-            <a:ext cx="3017520" cy="274320"/>
-          </a:xfrm>
-          <a:prstGeom prst="rect">
-            <a:avLst/>
-          </a:prstGeom>
-          <a:noFill/>
-        </p:spPr>
-        <p:txBody>
-          <a:bodyPr wrap="square" lIns="0" rIns="0" tIns="0" bIns="0">
-            <a:spAutoFit/>
-          </a:bodyPr>
-          <a:lstStyle/>
-          <a:p>
-            <a:pPr algn="ctr"/>
-            <a:r>
-              <a:rPr sz="1900" b="1">
-                <a:solidFill>
-                  <a:srgbClr val="FFFFFF"/>
-                </a:solidFill>
-                <a:latin typeface="Arial Unicode MS"/>
-                <a:ea typeface="Arial Unicode MS"/>
-                <a:cs typeface="Arial Unicode MS"/>
-              </a:rPr>
-              <a:t>可配置的品牌 App</a:t>
-            </a:r>
-          </a:p>
-        </p:txBody>
-      </p:sp>
-      <p:sp>
-        <p:nvSpPr>
-          <p:cNvPr id="26" name="TextBox 25"/>
-          <p:cNvSpPr txBox="1"/>
-          <p:nvPr/>
-        </p:nvSpPr>
-        <p:spPr>
-          <a:xfrm>
-            <a:off x="6995160" y="2606040"/>
-            <a:ext cx="1280160" cy="201168"/>
-          </a:xfrm>
-          <a:prstGeom prst="rect">
-            <a:avLst/>
-          </a:prstGeom>
-          <a:noFill/>
-        </p:spPr>
-        <p:txBody>
-          <a:bodyPr wrap="square" lIns="0" rIns="0" tIns="0" bIns="0">
-            <a:spAutoFit/>
-          </a:bodyPr>
-          <a:lstStyle/>
-          <a:p>
-            <a:pPr algn="l"/>
-            <a:r>
-              <a:rPr sz="1300" b="1">
-                <a:solidFill>
-                  <a:srgbClr val="D7AA4B"/>
-                </a:solidFill>
-                <a:latin typeface="Arial Unicode MS"/>
-                <a:ea typeface="Arial Unicode MS"/>
-                <a:cs typeface="Arial Unicode MS"/>
-              </a:rPr>
-              <a:t>品牌配置</a:t>
-            </a:r>
-          </a:p>
-        </p:txBody>
-      </p:sp>
-      <p:sp>
-        <p:nvSpPr>
-          <p:cNvPr id="27" name="TextBox 26"/>
-          <p:cNvSpPr txBox="1"/>
-          <p:nvPr/>
-        </p:nvSpPr>
-        <p:spPr>
-          <a:xfrm>
-            <a:off x="8503920" y="2606040"/>
-            <a:ext cx="1554480" cy="201168"/>
-          </a:xfrm>
-          <a:prstGeom prst="rect">
-            <a:avLst/>
-          </a:prstGeom>
-          <a:noFill/>
-        </p:spPr>
-        <p:txBody>
-          <a:bodyPr wrap="square" lIns="0" rIns="0" tIns="0" bIns="0">
-            <a:spAutoFit/>
-          </a:bodyPr>
-          <a:lstStyle/>
-          <a:p>
-            <a:pPr algn="l"/>
-            <a:r>
-              <a:rPr sz="1300" b="1">
-                <a:solidFill>
-                  <a:srgbClr val="B4C4E0"/>
-                </a:solidFill>
-                <a:latin typeface="Arial Unicode MS"/>
-                <a:ea typeface="Arial Unicode MS"/>
-                <a:cs typeface="Arial Unicode MS"/>
-              </a:rPr>
-              <a:t>内容与模块配置</a:t>
-            </a:r>
-          </a:p>
-        </p:txBody>
-      </p:sp>
-      <p:sp>
-        <p:nvSpPr>
-          <p:cNvPr id="28" name="TextBox 27"/>
-          <p:cNvSpPr txBox="1"/>
-          <p:nvPr/>
-        </p:nvSpPr>
-        <p:spPr>
-          <a:xfrm>
-            <a:off x="8366760" y="3017520"/>
-            <a:ext cx="274320" cy="228600"/>
-          </a:xfrm>
-          <a:prstGeom prst="rect">
-            <a:avLst/>
-          </a:prstGeom>
-          <a:noFill/>
-        </p:spPr>
-        <p:txBody>
-          <a:bodyPr wrap="square" lIns="0" rIns="0" tIns="0" bIns="0">
-            <a:spAutoFit/>
-          </a:bodyPr>
-          <a:lstStyle/>
-          <a:p>
-            <a:pPr algn="ctr"/>
-            <a:r>
-              <a:rPr sz="1800" b="1">
-                <a:solidFill>
-                  <a:srgbClr val="FFFFFF"/>
-                </a:solidFill>
-                <a:latin typeface="Arial Unicode MS"/>
-                <a:ea typeface="Arial Unicode MS"/>
-                <a:cs typeface="Arial Unicode MS"/>
-              </a:rPr>
-              <a:t>↓</a:t>
-            </a:r>
-          </a:p>
-        </p:txBody>
-      </p:sp>
-      <p:sp>
-        <p:nvSpPr>
-          <p:cNvPr id="29" name="TextBox 28"/>
-          <p:cNvSpPr txBox="1"/>
-          <p:nvPr/>
-        </p:nvSpPr>
-        <p:spPr>
-          <a:xfrm>
-            <a:off x="6995160" y="3474720"/>
-            <a:ext cx="3017520" cy="228600"/>
-          </a:xfrm>
-          <a:prstGeom prst="rect">
-            <a:avLst/>
-          </a:prstGeom>
-          <a:noFill/>
-        </p:spPr>
-        <p:txBody>
-          <a:bodyPr wrap="square" lIns="0" rIns="0" tIns="0" bIns="0">
-            <a:spAutoFit/>
-          </a:bodyPr>
-          <a:lstStyle/>
-          <a:p>
-            <a:pPr algn="ctr"/>
-            <a:r>
-              <a:rPr sz="1500" b="1">
-                <a:solidFill>
-                  <a:srgbClr val="FFFFFF"/>
-                </a:solidFill>
-                <a:latin typeface="Arial Unicode MS"/>
-                <a:ea typeface="Arial Unicode MS"/>
-                <a:cs typeface="Arial Unicode MS"/>
-              </a:rPr>
-              <a:t>多端发布 / H5 与原生组合</a:t>
-            </a:r>
-          </a:p>
-        </p:txBody>
-      </p:sp>
-      <p:sp>
-        <p:nvSpPr>
-          <p:cNvPr id="30" name="TextBox 29"/>
-          <p:cNvSpPr txBox="1"/>
-          <p:nvPr/>
-        </p:nvSpPr>
-        <p:spPr>
-          <a:xfrm>
-            <a:off x="8366760" y="3977639"/>
-            <a:ext cx="274320" cy="228600"/>
-          </a:xfrm>
-          <a:prstGeom prst="rect">
-            <a:avLst/>
-          </a:prstGeom>
-          <a:noFill/>
-        </p:spPr>
-        <p:txBody>
-          <a:bodyPr wrap="square" lIns="0" rIns="0" tIns="0" bIns="0">
-            <a:spAutoFit/>
-          </a:bodyPr>
-          <a:lstStyle/>
-          <a:p>
-            <a:pPr algn="ctr"/>
-            <a:r>
-              <a:rPr sz="1800" b="1">
-                <a:solidFill>
-                  <a:srgbClr val="FFFFFF"/>
-                </a:solidFill>
-                <a:latin typeface="Arial Unicode MS"/>
-                <a:ea typeface="Arial Unicode MS"/>
-                <a:cs typeface="Arial Unicode MS"/>
-              </a:rPr>
-              <a:t>↓</a:t>
-            </a:r>
-          </a:p>
-        </p:txBody>
-      </p:sp>
-      <p:sp>
-        <p:nvSpPr>
-          <p:cNvPr id="31" name="TextBox 30"/>
-          <p:cNvSpPr txBox="1"/>
-          <p:nvPr/>
-        </p:nvSpPr>
-        <p:spPr>
-          <a:xfrm>
-            <a:off x="6995160" y="4434840"/>
-            <a:ext cx="3017520" cy="228600"/>
-          </a:xfrm>
-          <a:prstGeom prst="rect">
-            <a:avLst/>
-          </a:prstGeom>
-          <a:noFill/>
-        </p:spPr>
-        <p:txBody>
-          <a:bodyPr wrap="square" lIns="0" rIns="0" tIns="0" bIns="0">
-            <a:spAutoFit/>
-          </a:bodyPr>
-          <a:lstStyle/>
-          <a:p>
-            <a:pPr algn="ctr"/>
-            <a:r>
-              <a:rPr sz="1500" b="1">
-                <a:solidFill>
-                  <a:srgbClr val="D7AA4B"/>
-                </a:solidFill>
-                <a:latin typeface="Arial Unicode MS"/>
-                <a:ea typeface="Arial Unicode MS"/>
-                <a:cs typeface="Arial Unicode MS"/>
-              </a:rPr>
-              <a:t>合规、数据与运营可控</a:t>
-            </a:r>
-          </a:p>
-        </p:txBody>
-      </p:sp>
-      <p:sp>
-        <p:nvSpPr>
-          <p:cNvPr id="32" name="Rounded Rectangle 31"/>
-          <p:cNvSpPr/>
-          <p:nvPr/>
-        </p:nvSpPr>
-        <p:spPr>
-          <a:xfrm>
-            <a:off x="777240" y="5532120"/>
-            <a:ext cx="4846320" cy="502920"/>
+            <a:off x="7635240" y="4251960"/>
+            <a:ext cx="3017520" cy="1051560"/>
           </a:xfrm>
           <a:prstGeom prst="roundRect">
             <a:avLst/>
@@ -7824,94 +7597,20 @@
       </p:sp>
       <p:sp>
         <p:nvSpPr>
-          <p:cNvPr id="33" name="TextBox 32"/>
-          <p:cNvSpPr txBox="1"/>
-          <p:nvPr/>
-        </p:nvSpPr>
-        <p:spPr>
-          <a:xfrm>
-            <a:off x="987552" y="5669280"/>
-            <a:ext cx="822960" cy="164592"/>
-          </a:xfrm>
-          <a:prstGeom prst="rect">
-            <a:avLst/>
-          </a:prstGeom>
-          <a:noFill/>
-        </p:spPr>
-        <p:txBody>
-          <a:bodyPr wrap="square" lIns="0" rIns="0" tIns="0" bIns="0">
-            <a:spAutoFit/>
-          </a:bodyPr>
-          <a:lstStyle/>
-          <a:p>
-            <a:pPr algn="l"/>
-            <a:r>
-              <a:rPr sz="1100" b="1">
-                <a:solidFill>
-                  <a:srgbClr val="071B43"/>
-                </a:solidFill>
-                <a:latin typeface="Arial Unicode MS"/>
-                <a:ea typeface="Arial Unicode MS"/>
-                <a:cs typeface="Arial Unicode MS"/>
-              </a:rPr>
-              <a:t>展示主题</a:t>
-            </a:r>
-          </a:p>
-        </p:txBody>
-      </p:sp>
-      <p:sp>
-        <p:nvSpPr>
-          <p:cNvPr id="34" name="TextBox 33"/>
-          <p:cNvSpPr txBox="1"/>
-          <p:nvPr/>
-        </p:nvSpPr>
-        <p:spPr>
-          <a:xfrm>
-            <a:off x="1874519" y="5669280"/>
-            <a:ext cx="2148840" cy="164592"/>
-          </a:xfrm>
-          <a:prstGeom prst="rect">
-            <a:avLst/>
-          </a:prstGeom>
-          <a:noFill/>
-        </p:spPr>
-        <p:txBody>
-          <a:bodyPr wrap="square" lIns="0" rIns="0" tIns="0" bIns="0">
-            <a:spAutoFit/>
-          </a:bodyPr>
-          <a:lstStyle/>
-          <a:p>
-            <a:pPr algn="l"/>
-            <a:r>
-              <a:rPr sz="1000" b="0">
-                <a:solidFill>
-                  <a:srgbClr val="68748B"/>
-                </a:solidFill>
-                <a:latin typeface="Arial Unicode MS"/>
-                <a:ea typeface="Arial Unicode MS"/>
-                <a:cs typeface="Arial Unicode MS"/>
-              </a:rPr>
-              <a:t>深海蓝  ·  暖金棕  ·  青绿科技</a:t>
-            </a:r>
-          </a:p>
-        </p:txBody>
-      </p:sp>
-      <p:sp>
-        <p:nvSpPr>
-          <p:cNvPr id="35" name="Rounded Rectangle 34"/>
+          <p:cNvPr id="27" name="Rounded Rectangle 26"/>
           <p:cNvSpPr/>
           <p:nvPr/>
         </p:nvSpPr>
         <p:spPr>
           <a:xfrm>
-            <a:off x="4160520" y="5623560"/>
-            <a:ext cx="1143000" cy="274320"/>
+            <a:off x="7818119" y="4480560"/>
+            <a:ext cx="329184" cy="329184"/>
           </a:xfrm>
           <a:prstGeom prst="roundRect">
             <a:avLst/>
           </a:prstGeom>
           <a:solidFill>
-            <a:srgbClr val="1C53AE"/>
+            <a:srgbClr val="26977D"/>
           </a:solidFill>
           <a:ln>
             <a:noFill/>
@@ -7941,37 +7640,111 @@
       </p:sp>
       <p:sp>
         <p:nvSpPr>
-          <p:cNvPr id="36" name="TextBox 35"/>
-          <p:cNvSpPr txBox="1"/>
-          <p:nvPr/>
-        </p:nvSpPr>
-        <p:spPr>
-          <a:xfrm>
-            <a:off x="4242816" y="5678424"/>
-            <a:ext cx="987552" cy="128016"/>
-          </a:xfrm>
-          <a:prstGeom prst="rect">
-            <a:avLst/>
-          </a:prstGeom>
-          <a:noFill/>
-        </p:spPr>
-        <p:txBody>
-          <a:bodyPr wrap="square" lIns="0" rIns="0" tIns="0" bIns="0">
-            <a:spAutoFit/>
-          </a:bodyPr>
-          <a:lstStyle/>
-          <a:p>
-            <a:pPr algn="ctr"/>
-            <a:r>
-              <a:rPr sz="800" b="1">
-                <a:solidFill>
-                  <a:srgbClr val="FFFFFF"/>
-                </a:solidFill>
-                <a:latin typeface="Arial Unicode MS"/>
-                <a:ea typeface="Arial Unicode MS"/>
-                <a:cs typeface="Arial Unicode MS"/>
-              </a:rPr>
-              <a:t>关怀版（大字）</a:t>
+          <p:cNvPr id="28" name="TextBox 27"/>
+          <p:cNvSpPr txBox="1"/>
+          <p:nvPr/>
+        </p:nvSpPr>
+        <p:spPr>
+          <a:xfrm>
+            <a:off x="8293608" y="4434840"/>
+            <a:ext cx="2057400" cy="201168"/>
+          </a:xfrm>
+          <a:prstGeom prst="rect">
+            <a:avLst/>
+          </a:prstGeom>
+          <a:noFill/>
+        </p:spPr>
+        <p:txBody>
+          <a:bodyPr wrap="square" lIns="0" rIns="0" tIns="0" bIns="0">
+            <a:spAutoFit/>
+          </a:bodyPr>
+          <a:lstStyle/>
+          <a:p>
+            <a:pPr algn="l"/>
+            <a:r>
+              <a:rPr sz="1200" b="1">
+                <a:solidFill>
+                  <a:srgbClr val="071B43"/>
+                </a:solidFill>
+                <a:latin typeface="Arial Unicode MS"/>
+                <a:ea typeface="Arial Unicode MS"/>
+                <a:cs typeface="Arial Unicode MS"/>
+              </a:rPr>
+              <a:t>服务引导与人工转接</a:t>
+            </a:r>
+          </a:p>
+        </p:txBody>
+      </p:sp>
+      <p:sp>
+        <p:nvSpPr>
+          <p:cNvPr id="29" name="TextBox 28"/>
+          <p:cNvSpPr txBox="1"/>
+          <p:nvPr/>
+        </p:nvSpPr>
+        <p:spPr>
+          <a:xfrm>
+            <a:off x="7818119" y="4919472"/>
+            <a:ext cx="2560320" cy="256032"/>
+          </a:xfrm>
+          <a:prstGeom prst="rect">
+            <a:avLst/>
+          </a:prstGeom>
+          <a:noFill/>
+        </p:spPr>
+        <p:txBody>
+          <a:bodyPr wrap="square" lIns="0" rIns="0" tIns="0" bIns="0">
+            <a:spAutoFit/>
+          </a:bodyPr>
+          <a:lstStyle/>
+          <a:p>
+            <a:pPr algn="l"/>
+            <a:r>
+              <a:rPr sz="900" b="0">
+                <a:solidFill>
+                  <a:srgbClr val="68748B"/>
+                </a:solidFill>
+                <a:latin typeface="Arial Unicode MS"/>
+                <a:ea typeface="Arial Unicode MS"/>
+                <a:cs typeface="Arial Unicode MS"/>
+              </a:rPr>
+              <a:t>按客户 SOP 分流至客服、顾问或企微服务</a:t>
+            </a:r>
+          </a:p>
+        </p:txBody>
+      </p:sp>
+      <p:sp>
+        <p:nvSpPr>
+          <p:cNvPr id="30" name="TextBox 29"/>
+          <p:cNvSpPr txBox="1"/>
+          <p:nvPr/>
+        </p:nvSpPr>
+        <p:spPr>
+          <a:xfrm>
+            <a:off x="777240" y="5779008"/>
+            <a:ext cx="8961120" cy="256032"/>
+          </a:xfrm>
+          <a:prstGeom prst="rect">
+            <a:avLst/>
+          </a:prstGeom>
+          <a:noFill/>
+        </p:spPr>
+        <p:txBody>
+          <a:bodyPr wrap="square" lIns="0" rIns="0" tIns="0" bIns="0">
+            <a:spAutoFit/>
+          </a:bodyPr>
+          <a:lstStyle/>
+          <a:p>
+            <a:pPr algn="l"/>
+            <a:r>
+              <a:rPr sz="1200" b="1">
+                <a:solidFill>
+                  <a:srgbClr val="8F5C29"/>
+                </a:solidFill>
+                <a:latin typeface="Arial Unicode MS"/>
+                <a:ea typeface="Arial Unicode MS"/>
+                <a:cs typeface="Arial Unicode MS"/>
+              </a:rPr>
+              <a:t>AI 用于信息整理、学习辅助与服务引导；不构成投资建议或收益承诺。</a:t>
             </a:r>
           </a:p>
         </p:txBody>
@@ -8009,7 +7782,7 @@
             <a:avLst/>
           </a:prstGeom>
           <a:solidFill>
-            <a:srgbClr val="F2F5F9"/>
+            <a:srgbClr val="FFFFFF"/>
           </a:solidFill>
           <a:ln>
             <a:noFill/>
@@ -8167,7 +7940,7 @@
                 <a:ea typeface="Arial Unicode MS"/>
                 <a:cs typeface="Arial Unicode MS"/>
               </a:rPr>
-              <a:t>合规展示、信息安全与部分私有化部署</a:t>
+              <a:t>品牌、后台与合规能力</a:t>
             </a:r>
           </a:p>
         </p:txBody>
@@ -8211,51 +7984,14 @@
       </p:sp>
       <p:sp>
         <p:nvSpPr>
-          <p:cNvPr id="8" name="TextBox 7"/>
-          <p:cNvSpPr txBox="1"/>
-          <p:nvPr/>
-        </p:nvSpPr>
-        <p:spPr>
-          <a:xfrm>
-            <a:off x="777240" y="1234440"/>
-            <a:ext cx="7772400" cy="274320"/>
-          </a:xfrm>
-          <a:prstGeom prst="rect">
-            <a:avLst/>
-          </a:prstGeom>
-          <a:noFill/>
-        </p:spPr>
-        <p:txBody>
-          <a:bodyPr wrap="square" lIns="0" rIns="0" tIns="0" bIns="0">
-            <a:spAutoFit/>
-          </a:bodyPr>
-          <a:lstStyle/>
-          <a:p>
-            <a:pPr algn="l"/>
-            <a:r>
-              <a:rPr sz="1500" b="1">
-                <a:solidFill>
-                  <a:srgbClr val="071B43"/>
-                </a:solidFill>
-                <a:latin typeface="Arial Unicode MS"/>
-                <a:ea typeface="Arial Unicode MS"/>
-                <a:cs typeface="Arial Unicode MS"/>
-              </a:rPr>
-              <a:t>把合规要求做成产品能力，把数据边界做成部署选项。</a:t>
-            </a:r>
-          </a:p>
-        </p:txBody>
-      </p:sp>
-      <p:sp>
-        <p:nvSpPr>
-          <p:cNvPr id="9" name="Rounded Rectangle 8"/>
+          <p:cNvPr id="8" name="Rounded Rectangle 7"/>
           <p:cNvSpPr/>
           <p:nvPr/>
         </p:nvSpPr>
         <p:spPr>
           <a:xfrm>
-            <a:off x="777240" y="1874519"/>
-            <a:ext cx="2560320" cy="987552"/>
+            <a:off x="777240" y="1325880"/>
+            <a:ext cx="4846320" cy="896112"/>
           </a:xfrm>
           <a:prstGeom prst="roundRect">
             <a:avLst/>
@@ -8293,14 +8029,14 @@
       </p:sp>
       <p:sp>
         <p:nvSpPr>
-          <p:cNvPr id="10" name="Rounded Rectangle 9"/>
+          <p:cNvPr id="9" name="Rounded Rectangle 8"/>
           <p:cNvSpPr/>
           <p:nvPr/>
         </p:nvSpPr>
         <p:spPr>
           <a:xfrm>
-            <a:off x="777240" y="1874519"/>
-            <a:ext cx="73152" cy="987552"/>
+            <a:off x="987552" y="1545336"/>
+            <a:ext cx="128016" cy="457200"/>
           </a:xfrm>
           <a:prstGeom prst="roundRect">
             <a:avLst/>
@@ -8336,51 +8072,51 @@
       </p:sp>
       <p:sp>
         <p:nvSpPr>
+          <p:cNvPr id="10" name="TextBox 9"/>
+          <p:cNvSpPr txBox="1"/>
+          <p:nvPr/>
+        </p:nvSpPr>
+        <p:spPr>
+          <a:xfrm>
+            <a:off x="1417320" y="1508760"/>
+            <a:ext cx="1280160" cy="210312"/>
+          </a:xfrm>
+          <a:prstGeom prst="rect">
+            <a:avLst/>
+          </a:prstGeom>
+          <a:noFill/>
+        </p:spPr>
+        <p:txBody>
+          <a:bodyPr wrap="square" lIns="0" rIns="0" tIns="0" bIns="0">
+            <a:spAutoFit/>
+          </a:bodyPr>
+          <a:lstStyle/>
+          <a:p>
+            <a:pPr algn="l"/>
+            <a:r>
+              <a:rPr sz="1400" b="1">
+                <a:solidFill>
+                  <a:srgbClr val="071B43"/>
+                </a:solidFill>
+                <a:latin typeface="Arial Unicode MS"/>
+                <a:ea typeface="Arial Unicode MS"/>
+                <a:cs typeface="Arial Unicode MS"/>
+              </a:rPr>
+              <a:t>品牌能力</a:t>
+            </a:r>
+          </a:p>
+        </p:txBody>
+      </p:sp>
+      <p:sp>
+        <p:nvSpPr>
           <p:cNvPr id="11" name="TextBox 10"/>
           <p:cNvSpPr txBox="1"/>
           <p:nvPr/>
         </p:nvSpPr>
         <p:spPr>
           <a:xfrm>
-            <a:off x="1005840" y="2039112"/>
-            <a:ext cx="2057400" cy="210312"/>
-          </a:xfrm>
-          <a:prstGeom prst="rect">
-            <a:avLst/>
-          </a:prstGeom>
-          <a:noFill/>
-        </p:spPr>
-        <p:txBody>
-          <a:bodyPr wrap="square" lIns="0" rIns="0" tIns="0" bIns="0">
-            <a:spAutoFit/>
-          </a:bodyPr>
-          <a:lstStyle/>
-          <a:p>
-            <a:pPr algn="l"/>
-            <a:r>
-              <a:rPr sz="1400" b="1">
-                <a:solidFill>
-                  <a:srgbClr val="071B43"/>
-                </a:solidFill>
-                <a:latin typeface="Arial Unicode MS"/>
-                <a:ea typeface="Arial Unicode MS"/>
-                <a:cs typeface="Arial Unicode MS"/>
-              </a:rPr>
-              <a:t>合规组件</a:t>
-            </a:r>
-          </a:p>
-        </p:txBody>
-      </p:sp>
-      <p:sp>
-        <p:nvSpPr>
-          <p:cNvPr id="12" name="TextBox 11"/>
-          <p:cNvSpPr txBox="1"/>
-          <p:nvPr/>
-        </p:nvSpPr>
-        <p:spPr>
-          <a:xfrm>
-            <a:off x="1005840" y="2350008"/>
-            <a:ext cx="2057400" cy="365760"/>
+            <a:off x="2788920" y="1508760"/>
+            <a:ext cx="2468880" cy="384048"/>
           </a:xfrm>
           <a:prstGeom prst="rect">
             <a:avLst/>
@@ -8403,21 +8139,21 @@
                 <a:ea typeface="Arial Unicode MS"/>
                 <a:cs typeface="Arial Unicode MS"/>
               </a:rPr>
-              <a:t>R3/C3 适当性文案、风险提示、执业信息、隐私协议与 SDK 披露</a:t>
-            </a:r>
-          </a:p>
-        </p:txBody>
-      </p:sp>
-      <p:sp>
-        <p:nvSpPr>
-          <p:cNvPr id="13" name="Rounded Rectangle 12"/>
+              <a:t>Logo、主题色、首页 Banner、Tab 和页面风格可定制</a:t>
+            </a:r>
+          </a:p>
+        </p:txBody>
+      </p:sp>
+      <p:sp>
+        <p:nvSpPr>
+          <p:cNvPr id="12" name="Rounded Rectangle 11"/>
           <p:cNvSpPr/>
           <p:nvPr/>
         </p:nvSpPr>
         <p:spPr>
           <a:xfrm>
-            <a:off x="3749039" y="1874519"/>
-            <a:ext cx="2560320" cy="987552"/>
+            <a:off x="777240" y="2313432"/>
+            <a:ext cx="4846320" cy="896112"/>
           </a:xfrm>
           <a:prstGeom prst="roundRect">
             <a:avLst/>
@@ -8455,20 +8191,20 @@
       </p:sp>
       <p:sp>
         <p:nvSpPr>
-          <p:cNvPr id="14" name="Rounded Rectangle 13"/>
+          <p:cNvPr id="13" name="Rounded Rectangle 12"/>
           <p:cNvSpPr/>
           <p:nvPr/>
         </p:nvSpPr>
         <p:spPr>
           <a:xfrm>
-            <a:off x="3749039" y="1874519"/>
-            <a:ext cx="73152" cy="987552"/>
+            <a:off x="987552" y="2532888"/>
+            <a:ext cx="128016" cy="457200"/>
           </a:xfrm>
           <a:prstGeom prst="roundRect">
             <a:avLst/>
           </a:prstGeom>
           <a:solidFill>
-            <a:srgbClr val="26977D"/>
+            <a:srgbClr val="D7AA4B"/>
           </a:solidFill>
           <a:ln>
             <a:noFill/>
@@ -8498,51 +8234,51 @@
       </p:sp>
       <p:sp>
         <p:nvSpPr>
+          <p:cNvPr id="14" name="TextBox 13"/>
+          <p:cNvSpPr txBox="1"/>
+          <p:nvPr/>
+        </p:nvSpPr>
+        <p:spPr>
+          <a:xfrm>
+            <a:off x="1417320" y="2496312"/>
+            <a:ext cx="1280160" cy="210312"/>
+          </a:xfrm>
+          <a:prstGeom prst="rect">
+            <a:avLst/>
+          </a:prstGeom>
+          <a:noFill/>
+        </p:spPr>
+        <p:txBody>
+          <a:bodyPr wrap="square" lIns="0" rIns="0" tIns="0" bIns="0">
+            <a:spAutoFit/>
+          </a:bodyPr>
+          <a:lstStyle/>
+          <a:p>
+            <a:pPr algn="l"/>
+            <a:r>
+              <a:rPr sz="1400" b="1">
+                <a:solidFill>
+                  <a:srgbClr val="071B43"/>
+                </a:solidFill>
+                <a:latin typeface="Arial Unicode MS"/>
+                <a:ea typeface="Arial Unicode MS"/>
+                <a:cs typeface="Arial Unicode MS"/>
+              </a:rPr>
+              <a:t>后台能力</a:t>
+            </a:r>
+          </a:p>
+        </p:txBody>
+      </p:sp>
+      <p:sp>
+        <p:nvSpPr>
           <p:cNvPr id="15" name="TextBox 14"/>
           <p:cNvSpPr txBox="1"/>
           <p:nvPr/>
         </p:nvSpPr>
         <p:spPr>
           <a:xfrm>
-            <a:off x="3977639" y="2039112"/>
-            <a:ext cx="2057400" cy="210312"/>
-          </a:xfrm>
-          <a:prstGeom prst="rect">
-            <a:avLst/>
-          </a:prstGeom>
-          <a:noFill/>
-        </p:spPr>
-        <p:txBody>
-          <a:bodyPr wrap="square" lIns="0" rIns="0" tIns="0" bIns="0">
-            <a:spAutoFit/>
-          </a:bodyPr>
-          <a:lstStyle/>
-          <a:p>
-            <a:pPr algn="l"/>
-            <a:r>
-              <a:rPr sz="1400" b="1">
-                <a:solidFill>
-                  <a:srgbClr val="071B43"/>
-                </a:solidFill>
-                <a:latin typeface="Arial Unicode MS"/>
-                <a:ea typeface="Arial Unicode MS"/>
-                <a:cs typeface="Arial Unicode MS"/>
-              </a:rPr>
-              <a:t>安全控制</a:t>
-            </a:r>
-          </a:p>
-        </p:txBody>
-      </p:sp>
-      <p:sp>
-        <p:nvSpPr>
-          <p:cNvPr id="16" name="TextBox 15"/>
-          <p:cNvSpPr txBox="1"/>
-          <p:nvPr/>
-        </p:nvSpPr>
-        <p:spPr>
-          <a:xfrm>
-            <a:off x="3977639" y="2350008"/>
-            <a:ext cx="2057400" cy="365760"/>
+            <a:off x="2788920" y="2496312"/>
+            <a:ext cx="2468880" cy="384048"/>
           </a:xfrm>
           <a:prstGeom prst="rect">
             <a:avLst/>
@@ -8565,21 +8301,21 @@
                 <a:ea typeface="Arial Unicode MS"/>
                 <a:cs typeface="Arial Unicode MS"/>
               </a:rPr>
-              <a:t>传输与存储加密、最小权限、租户隔离、敏感操作审计留痕</a:t>
-            </a:r>
-          </a:p>
-        </p:txBody>
-      </p:sp>
-      <p:sp>
-        <p:nvSpPr>
-          <p:cNvPr id="17" name="Rounded Rectangle 16"/>
+              <a:t>内容、课程、圈子、直播、消息和用户标签统一运营</a:t>
+            </a:r>
+          </a:p>
+        </p:txBody>
+      </p:sp>
+      <p:sp>
+        <p:nvSpPr>
+          <p:cNvPr id="16" name="Rounded Rectangle 15"/>
           <p:cNvSpPr/>
           <p:nvPr/>
         </p:nvSpPr>
         <p:spPr>
           <a:xfrm>
-            <a:off x="777240" y="3108960"/>
-            <a:ext cx="2560320" cy="987552"/>
+            <a:off x="777240" y="3300984"/>
+            <a:ext cx="4846320" cy="896112"/>
           </a:xfrm>
           <a:prstGeom prst="roundRect">
             <a:avLst/>
@@ -8617,20 +8353,20 @@
       </p:sp>
       <p:sp>
         <p:nvSpPr>
-          <p:cNvPr id="18" name="Rounded Rectangle 17"/>
+          <p:cNvPr id="17" name="Rounded Rectangle 16"/>
           <p:cNvSpPr/>
           <p:nvPr/>
         </p:nvSpPr>
         <p:spPr>
           <a:xfrm>
-            <a:off x="777240" y="3108960"/>
-            <a:ext cx="73152" cy="987552"/>
+            <a:off x="987552" y="3520440"/>
+            <a:ext cx="128016" cy="457200"/>
           </a:xfrm>
           <a:prstGeom prst="roundRect">
             <a:avLst/>
           </a:prstGeom>
           <a:solidFill>
-            <a:srgbClr val="D7AA4B"/>
+            <a:srgbClr val="26977D"/>
           </a:solidFill>
           <a:ln>
             <a:noFill/>
@@ -8660,51 +8396,51 @@
       </p:sp>
       <p:sp>
         <p:nvSpPr>
+          <p:cNvPr id="18" name="TextBox 17"/>
+          <p:cNvSpPr txBox="1"/>
+          <p:nvPr/>
+        </p:nvSpPr>
+        <p:spPr>
+          <a:xfrm>
+            <a:off x="1417320" y="3483864"/>
+            <a:ext cx="1280160" cy="210312"/>
+          </a:xfrm>
+          <a:prstGeom prst="rect">
+            <a:avLst/>
+          </a:prstGeom>
+          <a:noFill/>
+        </p:spPr>
+        <p:txBody>
+          <a:bodyPr wrap="square" lIns="0" rIns="0" tIns="0" bIns="0">
+            <a:spAutoFit/>
+          </a:bodyPr>
+          <a:lstStyle/>
+          <a:p>
+            <a:pPr algn="l"/>
+            <a:r>
+              <a:rPr sz="1400" b="1">
+                <a:solidFill>
+                  <a:srgbClr val="071B43"/>
+                </a:solidFill>
+                <a:latin typeface="Arial Unicode MS"/>
+                <a:ea typeface="Arial Unicode MS"/>
+                <a:cs typeface="Arial Unicode MS"/>
+              </a:rPr>
+              <a:t>定制开发</a:t>
+            </a:r>
+          </a:p>
+        </p:txBody>
+      </p:sp>
+      <p:sp>
+        <p:nvSpPr>
           <p:cNvPr id="19" name="TextBox 18"/>
           <p:cNvSpPr txBox="1"/>
           <p:nvPr/>
         </p:nvSpPr>
         <p:spPr>
           <a:xfrm>
-            <a:off x="1005840" y="3273552"/>
-            <a:ext cx="2057400" cy="210312"/>
-          </a:xfrm>
-          <a:prstGeom prst="rect">
-            <a:avLst/>
-          </a:prstGeom>
-          <a:noFill/>
-        </p:spPr>
-        <p:txBody>
-          <a:bodyPr wrap="square" lIns="0" rIns="0" tIns="0" bIns="0">
-            <a:spAutoFit/>
-          </a:bodyPr>
-          <a:lstStyle/>
-          <a:p>
-            <a:pPr algn="l"/>
-            <a:r>
-              <a:rPr sz="1400" b="1">
-                <a:solidFill>
-                  <a:srgbClr val="071B43"/>
-                </a:solidFill>
-                <a:latin typeface="Arial Unicode MS"/>
-                <a:ea typeface="Arial Unicode MS"/>
-                <a:cs typeface="Arial Unicode MS"/>
-              </a:rPr>
-              <a:t>数据边界</a:t>
-            </a:r>
-          </a:p>
-        </p:txBody>
-      </p:sp>
-      <p:sp>
-        <p:nvSpPr>
-          <p:cNvPr id="20" name="TextBox 19"/>
-          <p:cNvSpPr txBox="1"/>
-          <p:nvPr/>
-        </p:nvSpPr>
-        <p:spPr>
-          <a:xfrm>
-            <a:off x="1005840" y="3584448"/>
-            <a:ext cx="2057400" cy="365760"/>
+            <a:off x="2788920" y="3483864"/>
+            <a:ext cx="2468880" cy="384048"/>
           </a:xfrm>
           <a:prstGeom prst="rect">
             <a:avLst/>
@@ -8727,21 +8463,21 @@
                 <a:ea typeface="Arial Unicode MS"/>
                 <a:cs typeface="Arial Unicode MS"/>
               </a:rPr>
-              <a:t>用户、业务数据和审计日志可按客户安全域部署与管理</a:t>
-            </a:r>
-          </a:p>
-        </p:txBody>
-      </p:sp>
-      <p:sp>
-        <p:nvSpPr>
-          <p:cNvPr id="21" name="Rounded Rectangle 20"/>
+              <a:t>根据客户业务流程，提供页面、接口、数据和运营能力的定制开发</a:t>
+            </a:r>
+          </a:p>
+        </p:txBody>
+      </p:sp>
+      <p:sp>
+        <p:nvSpPr>
+          <p:cNvPr id="20" name="Rounded Rectangle 19"/>
           <p:cNvSpPr/>
           <p:nvPr/>
         </p:nvSpPr>
         <p:spPr>
           <a:xfrm>
-            <a:off x="3749039" y="3108960"/>
-            <a:ext cx="2560320" cy="987552"/>
+            <a:off x="777240" y="4288536"/>
+            <a:ext cx="4846320" cy="896112"/>
           </a:xfrm>
           <a:prstGeom prst="roundRect">
             <a:avLst/>
@@ -8779,14 +8515,14 @@
       </p:sp>
       <p:sp>
         <p:nvSpPr>
-          <p:cNvPr id="22" name="Rounded Rectangle 21"/>
+          <p:cNvPr id="21" name="Rounded Rectangle 20"/>
           <p:cNvSpPr/>
           <p:nvPr/>
         </p:nvSpPr>
         <p:spPr>
           <a:xfrm>
-            <a:off x="3749039" y="3108960"/>
-            <a:ext cx="73152" cy="987552"/>
+            <a:off x="987552" y="4507992"/>
+            <a:ext cx="128016" cy="457200"/>
           </a:xfrm>
           <a:prstGeom prst="roundRect">
             <a:avLst/>
@@ -8822,51 +8558,51 @@
       </p:sp>
       <p:sp>
         <p:nvSpPr>
+          <p:cNvPr id="22" name="TextBox 21"/>
+          <p:cNvSpPr txBox="1"/>
+          <p:nvPr/>
+        </p:nvSpPr>
+        <p:spPr>
+          <a:xfrm>
+            <a:off x="1417320" y="4471416"/>
+            <a:ext cx="1280160" cy="210312"/>
+          </a:xfrm>
+          <a:prstGeom prst="rect">
+            <a:avLst/>
+          </a:prstGeom>
+          <a:noFill/>
+        </p:spPr>
+        <p:txBody>
+          <a:bodyPr wrap="square" lIns="0" rIns="0" tIns="0" bIns="0">
+            <a:spAutoFit/>
+          </a:bodyPr>
+          <a:lstStyle/>
+          <a:p>
+            <a:pPr algn="l"/>
+            <a:r>
+              <a:rPr sz="1400" b="1">
+                <a:solidFill>
+                  <a:srgbClr val="071B43"/>
+                </a:solidFill>
+                <a:latin typeface="Arial Unicode MS"/>
+                <a:ea typeface="Arial Unicode MS"/>
+                <a:cs typeface="Arial Unicode MS"/>
+              </a:rPr>
+              <a:t>合规能力</a:t>
+            </a:r>
+          </a:p>
+        </p:txBody>
+      </p:sp>
+      <p:sp>
+        <p:nvSpPr>
           <p:cNvPr id="23" name="TextBox 22"/>
           <p:cNvSpPr txBox="1"/>
           <p:nvPr/>
         </p:nvSpPr>
         <p:spPr>
           <a:xfrm>
-            <a:off x="3977639" y="3273552"/>
-            <a:ext cx="2057400" cy="210312"/>
-          </a:xfrm>
-          <a:prstGeom prst="rect">
-            <a:avLst/>
-          </a:prstGeom>
-          <a:noFill/>
-        </p:spPr>
-        <p:txBody>
-          <a:bodyPr wrap="square" lIns="0" rIns="0" tIns="0" bIns="0">
-            <a:spAutoFit/>
-          </a:bodyPr>
-          <a:lstStyle/>
-          <a:p>
-            <a:pPr algn="l"/>
-            <a:r>
-              <a:rPr sz="1400" b="1">
-                <a:solidFill>
-                  <a:srgbClr val="071B43"/>
-                </a:solidFill>
-                <a:latin typeface="Arial Unicode MS"/>
-                <a:ea typeface="Arial Unicode MS"/>
-                <a:cs typeface="Arial Unicode MS"/>
-              </a:rPr>
-              <a:t>部署方式</a:t>
-            </a:r>
-          </a:p>
-        </p:txBody>
-      </p:sp>
-      <p:sp>
-        <p:nvSpPr>
-          <p:cNvPr id="24" name="TextBox 23"/>
-          <p:cNvSpPr txBox="1"/>
-          <p:nvPr/>
-        </p:nvSpPr>
-        <p:spPr>
-          <a:xfrm>
-            <a:off x="3977639" y="3584448"/>
-            <a:ext cx="2057400" cy="365760"/>
+            <a:off x="2788920" y="4471416"/>
+            <a:ext cx="2468880" cy="384048"/>
           </a:xfrm>
           <a:prstGeom prst="rect">
             <a:avLst/>
@@ -8889,21 +8625,21 @@
                 <a:ea typeface="Arial Unicode MS"/>
                 <a:cs typeface="Arial Unicode MS"/>
               </a:rPr>
-              <a:t>支持部分私有化部署；按客户安全边界组合部署，不等同于全量私有化</a:t>
-            </a:r>
-          </a:p>
-        </p:txBody>
-      </p:sp>
-      <p:sp>
-        <p:nvSpPr>
-          <p:cNvPr id="25" name="Rounded Rectangle 24"/>
+              <a:t>隐私协议、风险提示、执业信息、权限和内容审核可配置</a:t>
+            </a:r>
+          </a:p>
+        </p:txBody>
+      </p:sp>
+      <p:sp>
+        <p:nvSpPr>
+          <p:cNvPr id="24" name="Rounded Rectangle 23"/>
           <p:cNvSpPr/>
           <p:nvPr/>
         </p:nvSpPr>
         <p:spPr>
           <a:xfrm>
-            <a:off x="6812280" y="1691640"/>
-            <a:ext cx="3886200" cy="4160520"/>
+            <a:off x="6400800" y="1417320"/>
+            <a:ext cx="4160520" cy="4114800"/>
           </a:xfrm>
           <a:prstGeom prst="roundRect">
             <a:avLst/>
@@ -8939,14 +8675,125 @@
       </p:sp>
       <p:sp>
         <p:nvSpPr>
+          <p:cNvPr id="25" name="TextBox 24"/>
+          <p:cNvSpPr txBox="1"/>
+          <p:nvPr/>
+        </p:nvSpPr>
+        <p:spPr>
+          <a:xfrm>
+            <a:off x="6995160" y="1828800"/>
+            <a:ext cx="3017520" cy="274320"/>
+          </a:xfrm>
+          <a:prstGeom prst="rect">
+            <a:avLst/>
+          </a:prstGeom>
+          <a:noFill/>
+        </p:spPr>
+        <p:txBody>
+          <a:bodyPr wrap="square" lIns="0" rIns="0" tIns="0" bIns="0">
+            <a:spAutoFit/>
+          </a:bodyPr>
+          <a:lstStyle/>
+          <a:p>
+            <a:pPr algn="ctr"/>
+            <a:r>
+              <a:rPr sz="1900" b="1">
+                <a:solidFill>
+                  <a:srgbClr val="FFFFFF"/>
+                </a:solidFill>
+                <a:latin typeface="Arial Unicode MS"/>
+                <a:ea typeface="Arial Unicode MS"/>
+                <a:cs typeface="Arial Unicode MS"/>
+              </a:rPr>
+              <a:t>可配置的品牌 App</a:t>
+            </a:r>
+          </a:p>
+        </p:txBody>
+      </p:sp>
+      <p:sp>
+        <p:nvSpPr>
           <p:cNvPr id="26" name="TextBox 25"/>
           <p:cNvSpPr txBox="1"/>
           <p:nvPr/>
         </p:nvSpPr>
         <p:spPr>
           <a:xfrm>
-            <a:off x="7223760" y="2011680"/>
-            <a:ext cx="3063240" cy="256032"/>
+            <a:off x="6995160" y="2606040"/>
+            <a:ext cx="1280160" cy="201168"/>
+          </a:xfrm>
+          <a:prstGeom prst="rect">
+            <a:avLst/>
+          </a:prstGeom>
+          <a:noFill/>
+        </p:spPr>
+        <p:txBody>
+          <a:bodyPr wrap="square" lIns="0" rIns="0" tIns="0" bIns="0">
+            <a:spAutoFit/>
+          </a:bodyPr>
+          <a:lstStyle/>
+          <a:p>
+            <a:pPr algn="l"/>
+            <a:r>
+              <a:rPr sz="1300" b="1">
+                <a:solidFill>
+                  <a:srgbClr val="D7AA4B"/>
+                </a:solidFill>
+                <a:latin typeface="Arial Unicode MS"/>
+                <a:ea typeface="Arial Unicode MS"/>
+                <a:cs typeface="Arial Unicode MS"/>
+              </a:rPr>
+              <a:t>品牌配置</a:t>
+            </a:r>
+          </a:p>
+        </p:txBody>
+      </p:sp>
+      <p:sp>
+        <p:nvSpPr>
+          <p:cNvPr id="27" name="TextBox 26"/>
+          <p:cNvSpPr txBox="1"/>
+          <p:nvPr/>
+        </p:nvSpPr>
+        <p:spPr>
+          <a:xfrm>
+            <a:off x="8503920" y="2606040"/>
+            <a:ext cx="1554480" cy="201168"/>
+          </a:xfrm>
+          <a:prstGeom prst="rect">
+            <a:avLst/>
+          </a:prstGeom>
+          <a:noFill/>
+        </p:spPr>
+        <p:txBody>
+          <a:bodyPr wrap="square" lIns="0" rIns="0" tIns="0" bIns="0">
+            <a:spAutoFit/>
+          </a:bodyPr>
+          <a:lstStyle/>
+          <a:p>
+            <a:pPr algn="l"/>
+            <a:r>
+              <a:rPr sz="1300" b="1">
+                <a:solidFill>
+                  <a:srgbClr val="B4C4E0"/>
+                </a:solidFill>
+                <a:latin typeface="Arial Unicode MS"/>
+                <a:ea typeface="Arial Unicode MS"/>
+                <a:cs typeface="Arial Unicode MS"/>
+              </a:rPr>
+              <a:t>内容与模块配置</a:t>
+            </a:r>
+          </a:p>
+        </p:txBody>
+      </p:sp>
+      <p:sp>
+        <p:nvSpPr>
+          <p:cNvPr id="28" name="TextBox 27"/>
+          <p:cNvSpPr txBox="1"/>
+          <p:nvPr/>
+        </p:nvSpPr>
+        <p:spPr>
+          <a:xfrm>
+            <a:off x="8366760" y="3017520"/>
+            <a:ext cx="274320" cy="228600"/>
           </a:xfrm>
           <a:prstGeom prst="rect">
             <a:avLst/>
@@ -8969,30 +8816,143 @@
                 <a:ea typeface="Arial Unicode MS"/>
                 <a:cs typeface="Arial Unicode MS"/>
               </a:rPr>
-              <a:t>按安全边界组合部署</a:t>
-            </a:r>
-          </a:p>
-        </p:txBody>
-      </p:sp>
-      <p:sp>
-        <p:nvSpPr>
-          <p:cNvPr id="27" name="Rounded Rectangle 26"/>
+              <a:t>↓</a:t>
+            </a:r>
+          </a:p>
+        </p:txBody>
+      </p:sp>
+      <p:sp>
+        <p:nvSpPr>
+          <p:cNvPr id="29" name="TextBox 28"/>
+          <p:cNvSpPr txBox="1"/>
+          <p:nvPr/>
+        </p:nvSpPr>
+        <p:spPr>
+          <a:xfrm>
+            <a:off x="6995160" y="3474720"/>
+            <a:ext cx="3017520" cy="228600"/>
+          </a:xfrm>
+          <a:prstGeom prst="rect">
+            <a:avLst/>
+          </a:prstGeom>
+          <a:noFill/>
+        </p:spPr>
+        <p:txBody>
+          <a:bodyPr wrap="square" lIns="0" rIns="0" tIns="0" bIns="0">
+            <a:spAutoFit/>
+          </a:bodyPr>
+          <a:lstStyle/>
+          <a:p>
+            <a:pPr algn="ctr"/>
+            <a:r>
+              <a:rPr sz="1500" b="1">
+                <a:solidFill>
+                  <a:srgbClr val="FFFFFF"/>
+                </a:solidFill>
+                <a:latin typeface="Arial Unicode MS"/>
+                <a:ea typeface="Arial Unicode MS"/>
+                <a:cs typeface="Arial Unicode MS"/>
+              </a:rPr>
+              <a:t>多端发布 / H5 与原生组合</a:t>
+            </a:r>
+          </a:p>
+        </p:txBody>
+      </p:sp>
+      <p:sp>
+        <p:nvSpPr>
+          <p:cNvPr id="30" name="TextBox 29"/>
+          <p:cNvSpPr txBox="1"/>
+          <p:nvPr/>
+        </p:nvSpPr>
+        <p:spPr>
+          <a:xfrm>
+            <a:off x="8366760" y="3977639"/>
+            <a:ext cx="274320" cy="228600"/>
+          </a:xfrm>
+          <a:prstGeom prst="rect">
+            <a:avLst/>
+          </a:prstGeom>
+          <a:noFill/>
+        </p:spPr>
+        <p:txBody>
+          <a:bodyPr wrap="square" lIns="0" rIns="0" tIns="0" bIns="0">
+            <a:spAutoFit/>
+          </a:bodyPr>
+          <a:lstStyle/>
+          <a:p>
+            <a:pPr algn="ctr"/>
+            <a:r>
+              <a:rPr sz="1800" b="1">
+                <a:solidFill>
+                  <a:srgbClr val="FFFFFF"/>
+                </a:solidFill>
+                <a:latin typeface="Arial Unicode MS"/>
+                <a:ea typeface="Arial Unicode MS"/>
+                <a:cs typeface="Arial Unicode MS"/>
+              </a:rPr>
+              <a:t>↓</a:t>
+            </a:r>
+          </a:p>
+        </p:txBody>
+      </p:sp>
+      <p:sp>
+        <p:nvSpPr>
+          <p:cNvPr id="31" name="TextBox 30"/>
+          <p:cNvSpPr txBox="1"/>
+          <p:nvPr/>
+        </p:nvSpPr>
+        <p:spPr>
+          <a:xfrm>
+            <a:off x="6995160" y="4434840"/>
+            <a:ext cx="3017520" cy="228600"/>
+          </a:xfrm>
+          <a:prstGeom prst="rect">
+            <a:avLst/>
+          </a:prstGeom>
+          <a:noFill/>
+        </p:spPr>
+        <p:txBody>
+          <a:bodyPr wrap="square" lIns="0" rIns="0" tIns="0" bIns="0">
+            <a:spAutoFit/>
+          </a:bodyPr>
+          <a:lstStyle/>
+          <a:p>
+            <a:pPr algn="ctr"/>
+            <a:r>
+              <a:rPr sz="1500" b="1">
+                <a:solidFill>
+                  <a:srgbClr val="D7AA4B"/>
+                </a:solidFill>
+                <a:latin typeface="Arial Unicode MS"/>
+                <a:ea typeface="Arial Unicode MS"/>
+                <a:cs typeface="Arial Unicode MS"/>
+              </a:rPr>
+              <a:t>合规、数据与运营可控</a:t>
+            </a:r>
+          </a:p>
+        </p:txBody>
+      </p:sp>
+      <p:sp>
+        <p:nvSpPr>
+          <p:cNvPr id="32" name="Rounded Rectangle 31"/>
           <p:cNvSpPr/>
           <p:nvPr/>
         </p:nvSpPr>
         <p:spPr>
           <a:xfrm>
-            <a:off x="7360920" y="2606040"/>
-            <a:ext cx="2788920" cy="658368"/>
+            <a:off x="777240" y="5532120"/>
+            <a:ext cx="4846320" cy="502920"/>
           </a:xfrm>
           <a:prstGeom prst="roundRect">
             <a:avLst/>
           </a:prstGeom>
           <a:solidFill>
-            <a:srgbClr val="1B4289"/>
+            <a:srgbClr val="FFFFFF"/>
           </a:solidFill>
-          <a:ln>
-            <a:noFill/>
+          <a:ln w="8890">
+            <a:solidFill>
+              <a:srgbClr val="E0E7F1"/>
+            </a:solidFill>
           </a:ln>
         </p:spPr>
         <p:style>
@@ -9019,131 +8979,94 @@
       </p:sp>
       <p:sp>
         <p:nvSpPr>
-          <p:cNvPr id="28" name="TextBox 27"/>
-          <p:cNvSpPr txBox="1"/>
-          <p:nvPr/>
-        </p:nvSpPr>
-        <p:spPr>
-          <a:xfrm>
-            <a:off x="7571231" y="2788920"/>
-            <a:ext cx="2377440" cy="182880"/>
-          </a:xfrm>
-          <a:prstGeom prst="rect">
-            <a:avLst/>
-          </a:prstGeom>
-          <a:noFill/>
-        </p:spPr>
-        <p:txBody>
-          <a:bodyPr wrap="square" lIns="0" rIns="0" tIns="0" bIns="0">
-            <a:spAutoFit/>
-          </a:bodyPr>
-          <a:lstStyle/>
-          <a:p>
-            <a:pPr algn="ctr"/>
-            <a:r>
-              <a:rPr sz="1300" b="1">
-                <a:solidFill>
-                  <a:srgbClr val="FFFFFF"/>
-                </a:solidFill>
-                <a:latin typeface="Arial Unicode MS"/>
-                <a:ea typeface="Arial Unicode MS"/>
-                <a:cs typeface="Arial Unicode MS"/>
-              </a:rPr>
-              <a:t>客户侧安全域</a:t>
-            </a:r>
-          </a:p>
-        </p:txBody>
-      </p:sp>
-      <p:sp>
-        <p:nvSpPr>
-          <p:cNvPr id="29" name="TextBox 28"/>
-          <p:cNvSpPr txBox="1"/>
-          <p:nvPr/>
-        </p:nvSpPr>
-        <p:spPr>
-          <a:xfrm>
-            <a:off x="7571231" y="3054096"/>
-            <a:ext cx="2377440" cy="164592"/>
-          </a:xfrm>
-          <a:prstGeom prst="rect">
-            <a:avLst/>
-          </a:prstGeom>
-          <a:noFill/>
-        </p:spPr>
-        <p:txBody>
-          <a:bodyPr wrap="square" lIns="0" rIns="0" tIns="0" bIns="0">
-            <a:spAutoFit/>
-          </a:bodyPr>
-          <a:lstStyle/>
-          <a:p>
-            <a:pPr algn="ctr"/>
-            <a:r>
-              <a:rPr sz="900" b="0">
-                <a:solidFill>
-                  <a:srgbClr val="BED3F0"/>
-                </a:solidFill>
-                <a:latin typeface="Arial Unicode MS"/>
-                <a:ea typeface="Arial Unicode MS"/>
-                <a:cs typeface="Arial Unicode MS"/>
-              </a:rPr>
-              <a:t>用户 / 业务数据 / 审计日志</a:t>
-            </a:r>
-          </a:p>
-        </p:txBody>
-      </p:sp>
-      <p:sp>
-        <p:nvSpPr>
-          <p:cNvPr id="30" name="TextBox 29"/>
-          <p:cNvSpPr txBox="1"/>
-          <p:nvPr/>
-        </p:nvSpPr>
-        <p:spPr>
-          <a:xfrm>
-            <a:off x="8577072" y="3456432"/>
-            <a:ext cx="228600" cy="228600"/>
-          </a:xfrm>
-          <a:prstGeom prst="rect">
-            <a:avLst/>
-          </a:prstGeom>
-          <a:noFill/>
-        </p:spPr>
-        <p:txBody>
-          <a:bodyPr wrap="square" lIns="0" rIns="0" tIns="0" bIns="0">
-            <a:spAutoFit/>
-          </a:bodyPr>
-          <a:lstStyle/>
-          <a:p>
-            <a:pPr algn="ctr"/>
-            <a:r>
-              <a:rPr sz="1700" b="1">
-                <a:solidFill>
-                  <a:srgbClr val="D7AA4B"/>
-                </a:solidFill>
-                <a:latin typeface="Arial Unicode MS"/>
-                <a:ea typeface="Arial Unicode MS"/>
-                <a:cs typeface="Arial Unicode MS"/>
-              </a:rPr>
-              <a:t>+</a:t>
-            </a:r>
-          </a:p>
-        </p:txBody>
-      </p:sp>
-      <p:sp>
-        <p:nvSpPr>
-          <p:cNvPr id="31" name="Rounded Rectangle 30"/>
+          <p:cNvPr id="33" name="TextBox 32"/>
+          <p:cNvSpPr txBox="1"/>
+          <p:nvPr/>
+        </p:nvSpPr>
+        <p:spPr>
+          <a:xfrm>
+            <a:off x="987552" y="5669280"/>
+            <a:ext cx="822960" cy="164592"/>
+          </a:xfrm>
+          <a:prstGeom prst="rect">
+            <a:avLst/>
+          </a:prstGeom>
+          <a:noFill/>
+        </p:spPr>
+        <p:txBody>
+          <a:bodyPr wrap="square" lIns="0" rIns="0" tIns="0" bIns="0">
+            <a:spAutoFit/>
+          </a:bodyPr>
+          <a:lstStyle/>
+          <a:p>
+            <a:pPr algn="l"/>
+            <a:r>
+              <a:rPr sz="1100" b="1">
+                <a:solidFill>
+                  <a:srgbClr val="071B43"/>
+                </a:solidFill>
+                <a:latin typeface="Arial Unicode MS"/>
+                <a:ea typeface="Arial Unicode MS"/>
+                <a:cs typeface="Arial Unicode MS"/>
+              </a:rPr>
+              <a:t>展示主题</a:t>
+            </a:r>
+          </a:p>
+        </p:txBody>
+      </p:sp>
+      <p:sp>
+        <p:nvSpPr>
+          <p:cNvPr id="34" name="TextBox 33"/>
+          <p:cNvSpPr txBox="1"/>
+          <p:nvPr/>
+        </p:nvSpPr>
+        <p:spPr>
+          <a:xfrm>
+            <a:off x="1874519" y="5669280"/>
+            <a:ext cx="2148840" cy="164592"/>
+          </a:xfrm>
+          <a:prstGeom prst="rect">
+            <a:avLst/>
+          </a:prstGeom>
+          <a:noFill/>
+        </p:spPr>
+        <p:txBody>
+          <a:bodyPr wrap="square" lIns="0" rIns="0" tIns="0" bIns="0">
+            <a:spAutoFit/>
+          </a:bodyPr>
+          <a:lstStyle/>
+          <a:p>
+            <a:pPr algn="l"/>
+            <a:r>
+              <a:rPr sz="1000" b="0">
+                <a:solidFill>
+                  <a:srgbClr val="68748B"/>
+                </a:solidFill>
+                <a:latin typeface="Arial Unicode MS"/>
+                <a:ea typeface="Arial Unicode MS"/>
+                <a:cs typeface="Arial Unicode MS"/>
+              </a:rPr>
+              <a:t>深海蓝  ·  暖金棕  ·  青绿科技</a:t>
+            </a:r>
+          </a:p>
+        </p:txBody>
+      </p:sp>
+      <p:sp>
+        <p:nvSpPr>
+          <p:cNvPr id="35" name="Rounded Rectangle 34"/>
           <p:cNvSpPr/>
           <p:nvPr/>
         </p:nvSpPr>
         <p:spPr>
           <a:xfrm>
-            <a:off x="7360920" y="3858768"/>
-            <a:ext cx="2788920" cy="658368"/>
+            <a:off x="4160520" y="5623560"/>
+            <a:ext cx="1143000" cy="274320"/>
           </a:xfrm>
           <a:prstGeom prst="roundRect">
             <a:avLst/>
           </a:prstGeom>
           <a:solidFill>
-            <a:srgbClr val="1E746F"/>
+            <a:srgbClr val="1C53AE"/>
           </a:solidFill>
           <a:ln>
             <a:noFill/>
@@ -9173,14 +9096,14 @@
       </p:sp>
       <p:sp>
         <p:nvSpPr>
-          <p:cNvPr id="32" name="TextBox 31"/>
-          <p:cNvSpPr txBox="1"/>
-          <p:nvPr/>
-        </p:nvSpPr>
-        <p:spPr>
-          <a:xfrm>
-            <a:off x="7571231" y="4041648"/>
-            <a:ext cx="2377440" cy="182880"/>
+          <p:cNvPr id="36" name="TextBox 35"/>
+          <p:cNvSpPr txBox="1"/>
+          <p:nvPr/>
+        </p:nvSpPr>
+        <p:spPr>
+          <a:xfrm>
+            <a:off x="4242816" y="5678424"/>
+            <a:ext cx="987552" cy="128016"/>
           </a:xfrm>
           <a:prstGeom prst="rect">
             <a:avLst/>
@@ -9195,7 +9118,7 @@
           <a:p>
             <a:pPr algn="ctr"/>
             <a:r>
-              <a:rPr sz="1300" b="1">
+              <a:rPr sz="800" b="1">
                 <a:solidFill>
                   <a:srgbClr val="FFFFFF"/>
                 </a:solidFill>
@@ -9203,81 +9126,7 @@
                 <a:ea typeface="Arial Unicode MS"/>
                 <a:cs typeface="Arial Unicode MS"/>
               </a:rPr>
-              <a:t>平台侧可选能力</a:t>
-            </a:r>
-          </a:p>
-        </p:txBody>
-      </p:sp>
-      <p:sp>
-        <p:nvSpPr>
-          <p:cNvPr id="33" name="TextBox 32"/>
-          <p:cNvSpPr txBox="1"/>
-          <p:nvPr/>
-        </p:nvSpPr>
-        <p:spPr>
-          <a:xfrm>
-            <a:off x="7571231" y="4306824"/>
-            <a:ext cx="2377440" cy="164592"/>
-          </a:xfrm>
-          <a:prstGeom prst="rect">
-            <a:avLst/>
-          </a:prstGeom>
-          <a:noFill/>
-        </p:spPr>
-        <p:txBody>
-          <a:bodyPr wrap="square" lIns="0" rIns="0" tIns="0" bIns="0">
-            <a:spAutoFit/>
-          </a:bodyPr>
-          <a:lstStyle/>
-          <a:p>
-            <a:pPr algn="ctr"/>
-            <a:r>
-              <a:rPr sz="900" b="0">
-                <a:solidFill>
-                  <a:srgbClr val="C3EBE2"/>
-                </a:solidFill>
-                <a:latin typeface="Arial Unicode MS"/>
-                <a:ea typeface="Arial Unicode MS"/>
-                <a:cs typeface="Arial Unicode MS"/>
-              </a:rPr>
-              <a:t>内容运营 / 消息 / 直播 / 版本服务</a:t>
-            </a:r>
-          </a:p>
-        </p:txBody>
-      </p:sp>
-      <p:sp>
-        <p:nvSpPr>
-          <p:cNvPr id="34" name="TextBox 33"/>
-          <p:cNvSpPr txBox="1"/>
-          <p:nvPr/>
-        </p:nvSpPr>
-        <p:spPr>
-          <a:xfrm>
-            <a:off x="7114032" y="5074920"/>
-            <a:ext cx="3246120" cy="411480"/>
-          </a:xfrm>
-          <a:prstGeom prst="rect">
-            <a:avLst/>
-          </a:prstGeom>
-          <a:noFill/>
-        </p:spPr>
-        <p:txBody>
-          <a:bodyPr wrap="square" lIns="0" rIns="0" tIns="0" bIns="0">
-            <a:spAutoFit/>
-          </a:bodyPr>
-          <a:lstStyle/>
-          <a:p>
-            <a:pPr algn="ctr"/>
-            <a:r>
-              <a:rPr sz="1000" b="0">
-                <a:solidFill>
-                  <a:srgbClr val="BED3F0"/>
-                </a:solidFill>
-                <a:latin typeface="Arial Unicode MS"/>
-                <a:ea typeface="Arial Unicode MS"/>
-                <a:cs typeface="Arial Unicode MS"/>
-              </a:rPr>
-              <a:t>部署组合需结合客户主体、数据分类分级与法务/安全评审确认。</a:t>
+              <a:t>关怀版（大字）</a:t>
             </a:r>
           </a:p>
         </p:txBody>
@@ -9291,6 +9140,1312 @@
 </file>
 
 <file path=ppt/slides/slide15.xml><?xml version="1.0" encoding="utf-8"?>
+<p:sld xmlns:a="http://schemas.openxmlformats.org/drawingml/2006/main" xmlns:p="http://schemas.openxmlformats.org/presentationml/2006/main" xmlns:r="http://schemas.openxmlformats.org/officeDocument/2006/relationships">
+  <p:cSld>
+    <p:spTree>
+      <p:nvGrpSpPr>
+        <p:cNvPr id="1" name=""/>
+        <p:cNvGrpSpPr/>
+        <p:nvPr/>
+      </p:nvGrpSpPr>
+      <p:grpSpPr/>
+      <p:sp>
+        <p:nvSpPr>
+          <p:cNvPr id="2" name="Rectangle 1"/>
+          <p:cNvSpPr/>
+          <p:nvPr/>
+        </p:nvSpPr>
+        <p:spPr>
+          <a:xfrm>
+            <a:off x="0" y="0"/>
+            <a:ext cx="12191695" cy="6858000"/>
+          </a:xfrm>
+          <a:prstGeom prst="rect">
+            <a:avLst/>
+          </a:prstGeom>
+          <a:solidFill>
+            <a:srgbClr val="F2F5F9"/>
+          </a:solidFill>
+          <a:ln>
+            <a:noFill/>
+          </a:ln>
+        </p:spPr>
+        <p:style>
+          <a:lnRef idx="1">
+            <a:schemeClr val="accent1"/>
+          </a:lnRef>
+          <a:fillRef idx="3">
+            <a:schemeClr val="accent1"/>
+          </a:fillRef>
+          <a:effectRef idx="2">
+            <a:schemeClr val="accent1"/>
+          </a:effectRef>
+          <a:fontRef idx="minor">
+            <a:schemeClr val="lt1"/>
+          </a:fontRef>
+        </p:style>
+        <p:txBody>
+          <a:bodyPr rtlCol="0" anchor="ctr"/>
+          <a:lstStyle/>
+          <a:p>
+            <a:pPr algn="ctr"/>
+          </a:p>
+        </p:txBody>
+      </p:sp>
+      <p:pic>
+        <p:nvPicPr>
+          <p:cNvPr id="3" name="Picture 2" descr="content-background.png"/>
+          <p:cNvPicPr>
+            <a:picLocks noChangeAspect="1"/>
+          </p:cNvPicPr>
+          <p:nvPr/>
+        </p:nvPicPr>
+        <p:blipFill>
+          <a:blip r:embed="rId2"/>
+          <a:stretch>
+            <a:fillRect/>
+          </a:stretch>
+        </p:blipFill>
+        <p:spPr>
+          <a:xfrm>
+            <a:off x="0" y="0"/>
+            <a:ext cx="12191695" cy="6858000"/>
+          </a:xfrm>
+          <a:prstGeom prst="rect">
+            <a:avLst/>
+          </a:prstGeom>
+        </p:spPr>
+      </p:pic>
+      <p:sp>
+        <p:nvSpPr>
+          <p:cNvPr id="4" name="TextBox 3"/>
+          <p:cNvSpPr txBox="1"/>
+          <p:nvPr/>
+        </p:nvSpPr>
+        <p:spPr>
+          <a:xfrm>
+            <a:off x="640080" y="6519672"/>
+            <a:ext cx="1828800" cy="164592"/>
+          </a:xfrm>
+          <a:prstGeom prst="rect">
+            <a:avLst/>
+          </a:prstGeom>
+          <a:noFill/>
+        </p:spPr>
+        <p:txBody>
+          <a:bodyPr wrap="square" lIns="0" rIns="0" tIns="0" bIns="0">
+            <a:spAutoFit/>
+          </a:bodyPr>
+          <a:lstStyle/>
+          <a:p>
+            <a:pPr algn="l"/>
+            <a:r>
+              <a:rPr sz="800" b="0">
+                <a:solidFill>
+                  <a:srgbClr val="99A3B2"/>
+                </a:solidFill>
+                <a:latin typeface="Arial Unicode MS"/>
+                <a:ea typeface="Arial Unicode MS"/>
+                <a:cs typeface="Arial Unicode MS"/>
+              </a:rPr>
+              <a:t>小鹅通·金融BU</a:t>
+            </a:r>
+          </a:p>
+        </p:txBody>
+      </p:sp>
+      <p:sp>
+        <p:nvSpPr>
+          <p:cNvPr id="5" name="TextBox 4"/>
+          <p:cNvSpPr txBox="1"/>
+          <p:nvPr/>
+        </p:nvSpPr>
+        <p:spPr>
+          <a:xfrm>
+            <a:off x="640080" y="438912"/>
+            <a:ext cx="3657600" cy="201168"/>
+          </a:xfrm>
+          <a:prstGeom prst="rect">
+            <a:avLst/>
+          </a:prstGeom>
+          <a:noFill/>
+        </p:spPr>
+        <p:txBody>
+          <a:bodyPr wrap="square" lIns="0" rIns="0" tIns="0" bIns="0">
+            <a:spAutoFit/>
+          </a:bodyPr>
+          <a:lstStyle/>
+          <a:p>
+            <a:pPr algn="l"/>
+            <a:r>
+              <a:rPr sz="900" b="0">
+                <a:solidFill>
+                  <a:srgbClr val="68748B"/>
+                </a:solidFill>
+                <a:latin typeface="Arial Unicode MS"/>
+                <a:ea typeface="Arial Unicode MS"/>
+                <a:cs typeface="Arial Unicode MS"/>
+              </a:rPr>
+              <a:t>金融行业自主私域 App 方案</a:t>
+            </a:r>
+          </a:p>
+        </p:txBody>
+      </p:sp>
+      <p:sp>
+        <p:nvSpPr>
+          <p:cNvPr id="6" name="TextBox 5"/>
+          <p:cNvSpPr txBox="1"/>
+          <p:nvPr/>
+        </p:nvSpPr>
+        <p:spPr>
+          <a:xfrm>
+            <a:off x="640080" y="749808"/>
+            <a:ext cx="7772400" cy="502920"/>
+          </a:xfrm>
+          <a:prstGeom prst="rect">
+            <a:avLst/>
+          </a:prstGeom>
+          <a:noFill/>
+        </p:spPr>
+        <p:txBody>
+          <a:bodyPr wrap="square" lIns="0" rIns="0" tIns="0" bIns="0">
+            <a:spAutoFit/>
+          </a:bodyPr>
+          <a:lstStyle/>
+          <a:p>
+            <a:pPr algn="l"/>
+            <a:r>
+              <a:rPr sz="2600" b="1">
+                <a:solidFill>
+                  <a:srgbClr val="071B43"/>
+                </a:solidFill>
+                <a:latin typeface="Arial Unicode MS"/>
+                <a:ea typeface="Arial Unicode MS"/>
+                <a:cs typeface="Arial Unicode MS"/>
+              </a:rPr>
+              <a:t>合规展示、信息安全与部分私有化部署</a:t>
+            </a:r>
+          </a:p>
+        </p:txBody>
+      </p:sp>
+      <p:sp>
+        <p:nvSpPr>
+          <p:cNvPr id="7" name="TextBox 6"/>
+          <p:cNvSpPr txBox="1"/>
+          <p:nvPr/>
+        </p:nvSpPr>
+        <p:spPr>
+          <a:xfrm>
+            <a:off x="11201400" y="502920"/>
+            <a:ext cx="411480" cy="228600"/>
+          </a:xfrm>
+          <a:prstGeom prst="rect">
+            <a:avLst/>
+          </a:prstGeom>
+          <a:noFill/>
+        </p:spPr>
+        <p:txBody>
+          <a:bodyPr wrap="square" lIns="0" rIns="0" tIns="0" bIns="0">
+            <a:spAutoFit/>
+          </a:bodyPr>
+          <a:lstStyle/>
+          <a:p>
+            <a:pPr algn="r"/>
+            <a:r>
+              <a:rPr sz="1000" b="1">
+                <a:solidFill>
+                  <a:srgbClr val="68748B"/>
+                </a:solidFill>
+                <a:latin typeface="Arial Unicode MS"/>
+                <a:ea typeface="Arial Unicode MS"/>
+                <a:cs typeface="Arial Unicode MS"/>
+              </a:rPr>
+              <a:t>15</a:t>
+            </a:r>
+          </a:p>
+        </p:txBody>
+      </p:sp>
+      <p:sp>
+        <p:nvSpPr>
+          <p:cNvPr id="8" name="TextBox 7"/>
+          <p:cNvSpPr txBox="1"/>
+          <p:nvPr/>
+        </p:nvSpPr>
+        <p:spPr>
+          <a:xfrm>
+            <a:off x="777240" y="1234440"/>
+            <a:ext cx="7772400" cy="274320"/>
+          </a:xfrm>
+          <a:prstGeom prst="rect">
+            <a:avLst/>
+          </a:prstGeom>
+          <a:noFill/>
+        </p:spPr>
+        <p:txBody>
+          <a:bodyPr wrap="square" lIns="0" rIns="0" tIns="0" bIns="0">
+            <a:spAutoFit/>
+          </a:bodyPr>
+          <a:lstStyle/>
+          <a:p>
+            <a:pPr algn="l"/>
+            <a:r>
+              <a:rPr sz="1500" b="1">
+                <a:solidFill>
+                  <a:srgbClr val="071B43"/>
+                </a:solidFill>
+                <a:latin typeface="Arial Unicode MS"/>
+                <a:ea typeface="Arial Unicode MS"/>
+                <a:cs typeface="Arial Unicode MS"/>
+              </a:rPr>
+              <a:t>把合规要求做成产品能力，把数据边界做成部署选项。</a:t>
+            </a:r>
+          </a:p>
+        </p:txBody>
+      </p:sp>
+      <p:sp>
+        <p:nvSpPr>
+          <p:cNvPr id="9" name="Rounded Rectangle 8"/>
+          <p:cNvSpPr/>
+          <p:nvPr/>
+        </p:nvSpPr>
+        <p:spPr>
+          <a:xfrm>
+            <a:off x="777240" y="1874519"/>
+            <a:ext cx="2560320" cy="987552"/>
+          </a:xfrm>
+          <a:prstGeom prst="roundRect">
+            <a:avLst/>
+          </a:prstGeom>
+          <a:solidFill>
+            <a:srgbClr val="FFFFFF"/>
+          </a:solidFill>
+          <a:ln w="8890">
+            <a:solidFill>
+              <a:srgbClr val="E0E7F1"/>
+            </a:solidFill>
+          </a:ln>
+        </p:spPr>
+        <p:style>
+          <a:lnRef idx="1">
+            <a:schemeClr val="accent1"/>
+          </a:lnRef>
+          <a:fillRef idx="3">
+            <a:schemeClr val="accent1"/>
+          </a:fillRef>
+          <a:effectRef idx="2">
+            <a:schemeClr val="accent1"/>
+          </a:effectRef>
+          <a:fontRef idx="minor">
+            <a:schemeClr val="lt1"/>
+          </a:fontRef>
+        </p:style>
+        <p:txBody>
+          <a:bodyPr rtlCol="0" anchor="ctr"/>
+          <a:lstStyle/>
+          <a:p>
+            <a:pPr algn="ctr"/>
+          </a:p>
+        </p:txBody>
+      </p:sp>
+      <p:sp>
+        <p:nvSpPr>
+          <p:cNvPr id="10" name="Rounded Rectangle 9"/>
+          <p:cNvSpPr/>
+          <p:nvPr/>
+        </p:nvSpPr>
+        <p:spPr>
+          <a:xfrm>
+            <a:off x="777240" y="1874519"/>
+            <a:ext cx="73152" cy="987552"/>
+          </a:xfrm>
+          <a:prstGeom prst="roundRect">
+            <a:avLst/>
+          </a:prstGeom>
+          <a:solidFill>
+            <a:srgbClr val="1C53AE"/>
+          </a:solidFill>
+          <a:ln>
+            <a:noFill/>
+          </a:ln>
+        </p:spPr>
+        <p:style>
+          <a:lnRef idx="1">
+            <a:schemeClr val="accent1"/>
+          </a:lnRef>
+          <a:fillRef idx="3">
+            <a:schemeClr val="accent1"/>
+          </a:fillRef>
+          <a:effectRef idx="2">
+            <a:schemeClr val="accent1"/>
+          </a:effectRef>
+          <a:fontRef idx="minor">
+            <a:schemeClr val="lt1"/>
+          </a:fontRef>
+        </p:style>
+        <p:txBody>
+          <a:bodyPr rtlCol="0" anchor="ctr"/>
+          <a:lstStyle/>
+          <a:p>
+            <a:pPr algn="ctr"/>
+          </a:p>
+        </p:txBody>
+      </p:sp>
+      <p:sp>
+        <p:nvSpPr>
+          <p:cNvPr id="11" name="TextBox 10"/>
+          <p:cNvSpPr txBox="1"/>
+          <p:nvPr/>
+        </p:nvSpPr>
+        <p:spPr>
+          <a:xfrm>
+            <a:off x="1005840" y="2039112"/>
+            <a:ext cx="2057400" cy="210312"/>
+          </a:xfrm>
+          <a:prstGeom prst="rect">
+            <a:avLst/>
+          </a:prstGeom>
+          <a:noFill/>
+        </p:spPr>
+        <p:txBody>
+          <a:bodyPr wrap="square" lIns="0" rIns="0" tIns="0" bIns="0">
+            <a:spAutoFit/>
+          </a:bodyPr>
+          <a:lstStyle/>
+          <a:p>
+            <a:pPr algn="l"/>
+            <a:r>
+              <a:rPr sz="1400" b="1">
+                <a:solidFill>
+                  <a:srgbClr val="071B43"/>
+                </a:solidFill>
+                <a:latin typeface="Arial Unicode MS"/>
+                <a:ea typeface="Arial Unicode MS"/>
+                <a:cs typeface="Arial Unicode MS"/>
+              </a:rPr>
+              <a:t>合规组件</a:t>
+            </a:r>
+          </a:p>
+        </p:txBody>
+      </p:sp>
+      <p:sp>
+        <p:nvSpPr>
+          <p:cNvPr id="12" name="TextBox 11"/>
+          <p:cNvSpPr txBox="1"/>
+          <p:nvPr/>
+        </p:nvSpPr>
+        <p:spPr>
+          <a:xfrm>
+            <a:off x="1005840" y="2350008"/>
+            <a:ext cx="2057400" cy="365760"/>
+          </a:xfrm>
+          <a:prstGeom prst="rect">
+            <a:avLst/>
+          </a:prstGeom>
+          <a:noFill/>
+        </p:spPr>
+        <p:txBody>
+          <a:bodyPr wrap="square" lIns="0" rIns="0" tIns="0" bIns="0">
+            <a:spAutoFit/>
+          </a:bodyPr>
+          <a:lstStyle/>
+          <a:p>
+            <a:pPr algn="l"/>
+            <a:r>
+              <a:rPr sz="1000" b="0">
+                <a:solidFill>
+                  <a:srgbClr val="68748B"/>
+                </a:solidFill>
+                <a:latin typeface="Arial Unicode MS"/>
+                <a:ea typeface="Arial Unicode MS"/>
+                <a:cs typeface="Arial Unicode MS"/>
+              </a:rPr>
+              <a:t>R3/C3 适当性文案、风险提示、执业信息、隐私协议与 SDK 披露</a:t>
+            </a:r>
+          </a:p>
+        </p:txBody>
+      </p:sp>
+      <p:sp>
+        <p:nvSpPr>
+          <p:cNvPr id="13" name="Rounded Rectangle 12"/>
+          <p:cNvSpPr/>
+          <p:nvPr/>
+        </p:nvSpPr>
+        <p:spPr>
+          <a:xfrm>
+            <a:off x="3749039" y="1874519"/>
+            <a:ext cx="2560320" cy="987552"/>
+          </a:xfrm>
+          <a:prstGeom prst="roundRect">
+            <a:avLst/>
+          </a:prstGeom>
+          <a:solidFill>
+            <a:srgbClr val="FFFFFF"/>
+          </a:solidFill>
+          <a:ln w="8890">
+            <a:solidFill>
+              <a:srgbClr val="E0E7F1"/>
+            </a:solidFill>
+          </a:ln>
+        </p:spPr>
+        <p:style>
+          <a:lnRef idx="1">
+            <a:schemeClr val="accent1"/>
+          </a:lnRef>
+          <a:fillRef idx="3">
+            <a:schemeClr val="accent1"/>
+          </a:fillRef>
+          <a:effectRef idx="2">
+            <a:schemeClr val="accent1"/>
+          </a:effectRef>
+          <a:fontRef idx="minor">
+            <a:schemeClr val="lt1"/>
+          </a:fontRef>
+        </p:style>
+        <p:txBody>
+          <a:bodyPr rtlCol="0" anchor="ctr"/>
+          <a:lstStyle/>
+          <a:p>
+            <a:pPr algn="ctr"/>
+          </a:p>
+        </p:txBody>
+      </p:sp>
+      <p:sp>
+        <p:nvSpPr>
+          <p:cNvPr id="14" name="Rounded Rectangle 13"/>
+          <p:cNvSpPr/>
+          <p:nvPr/>
+        </p:nvSpPr>
+        <p:spPr>
+          <a:xfrm>
+            <a:off x="3749039" y="1874519"/>
+            <a:ext cx="73152" cy="987552"/>
+          </a:xfrm>
+          <a:prstGeom prst="roundRect">
+            <a:avLst/>
+          </a:prstGeom>
+          <a:solidFill>
+            <a:srgbClr val="26977D"/>
+          </a:solidFill>
+          <a:ln>
+            <a:noFill/>
+          </a:ln>
+        </p:spPr>
+        <p:style>
+          <a:lnRef idx="1">
+            <a:schemeClr val="accent1"/>
+          </a:lnRef>
+          <a:fillRef idx="3">
+            <a:schemeClr val="accent1"/>
+          </a:fillRef>
+          <a:effectRef idx="2">
+            <a:schemeClr val="accent1"/>
+          </a:effectRef>
+          <a:fontRef idx="minor">
+            <a:schemeClr val="lt1"/>
+          </a:fontRef>
+        </p:style>
+        <p:txBody>
+          <a:bodyPr rtlCol="0" anchor="ctr"/>
+          <a:lstStyle/>
+          <a:p>
+            <a:pPr algn="ctr"/>
+          </a:p>
+        </p:txBody>
+      </p:sp>
+      <p:sp>
+        <p:nvSpPr>
+          <p:cNvPr id="15" name="TextBox 14"/>
+          <p:cNvSpPr txBox="1"/>
+          <p:nvPr/>
+        </p:nvSpPr>
+        <p:spPr>
+          <a:xfrm>
+            <a:off x="3977639" y="2039112"/>
+            <a:ext cx="2057400" cy="210312"/>
+          </a:xfrm>
+          <a:prstGeom prst="rect">
+            <a:avLst/>
+          </a:prstGeom>
+          <a:noFill/>
+        </p:spPr>
+        <p:txBody>
+          <a:bodyPr wrap="square" lIns="0" rIns="0" tIns="0" bIns="0">
+            <a:spAutoFit/>
+          </a:bodyPr>
+          <a:lstStyle/>
+          <a:p>
+            <a:pPr algn="l"/>
+            <a:r>
+              <a:rPr sz="1400" b="1">
+                <a:solidFill>
+                  <a:srgbClr val="071B43"/>
+                </a:solidFill>
+                <a:latin typeface="Arial Unicode MS"/>
+                <a:ea typeface="Arial Unicode MS"/>
+                <a:cs typeface="Arial Unicode MS"/>
+              </a:rPr>
+              <a:t>安全控制</a:t>
+            </a:r>
+          </a:p>
+        </p:txBody>
+      </p:sp>
+      <p:sp>
+        <p:nvSpPr>
+          <p:cNvPr id="16" name="TextBox 15"/>
+          <p:cNvSpPr txBox="1"/>
+          <p:nvPr/>
+        </p:nvSpPr>
+        <p:spPr>
+          <a:xfrm>
+            <a:off x="3977639" y="2350008"/>
+            <a:ext cx="2057400" cy="365760"/>
+          </a:xfrm>
+          <a:prstGeom prst="rect">
+            <a:avLst/>
+          </a:prstGeom>
+          <a:noFill/>
+        </p:spPr>
+        <p:txBody>
+          <a:bodyPr wrap="square" lIns="0" rIns="0" tIns="0" bIns="0">
+            <a:spAutoFit/>
+          </a:bodyPr>
+          <a:lstStyle/>
+          <a:p>
+            <a:pPr algn="l"/>
+            <a:r>
+              <a:rPr sz="1000" b="0">
+                <a:solidFill>
+                  <a:srgbClr val="68748B"/>
+                </a:solidFill>
+                <a:latin typeface="Arial Unicode MS"/>
+                <a:ea typeface="Arial Unicode MS"/>
+                <a:cs typeface="Arial Unicode MS"/>
+              </a:rPr>
+              <a:t>传输与存储加密、最小权限、租户隔离、敏感操作审计留痕</a:t>
+            </a:r>
+          </a:p>
+        </p:txBody>
+      </p:sp>
+      <p:sp>
+        <p:nvSpPr>
+          <p:cNvPr id="17" name="Rounded Rectangle 16"/>
+          <p:cNvSpPr/>
+          <p:nvPr/>
+        </p:nvSpPr>
+        <p:spPr>
+          <a:xfrm>
+            <a:off x="777240" y="3108960"/>
+            <a:ext cx="2560320" cy="987552"/>
+          </a:xfrm>
+          <a:prstGeom prst="roundRect">
+            <a:avLst/>
+          </a:prstGeom>
+          <a:solidFill>
+            <a:srgbClr val="FFFFFF"/>
+          </a:solidFill>
+          <a:ln w="8890">
+            <a:solidFill>
+              <a:srgbClr val="E0E7F1"/>
+            </a:solidFill>
+          </a:ln>
+        </p:spPr>
+        <p:style>
+          <a:lnRef idx="1">
+            <a:schemeClr val="accent1"/>
+          </a:lnRef>
+          <a:fillRef idx="3">
+            <a:schemeClr val="accent1"/>
+          </a:fillRef>
+          <a:effectRef idx="2">
+            <a:schemeClr val="accent1"/>
+          </a:effectRef>
+          <a:fontRef idx="minor">
+            <a:schemeClr val="lt1"/>
+          </a:fontRef>
+        </p:style>
+        <p:txBody>
+          <a:bodyPr rtlCol="0" anchor="ctr"/>
+          <a:lstStyle/>
+          <a:p>
+            <a:pPr algn="ctr"/>
+          </a:p>
+        </p:txBody>
+      </p:sp>
+      <p:sp>
+        <p:nvSpPr>
+          <p:cNvPr id="18" name="Rounded Rectangle 17"/>
+          <p:cNvSpPr/>
+          <p:nvPr/>
+        </p:nvSpPr>
+        <p:spPr>
+          <a:xfrm>
+            <a:off x="777240" y="3108960"/>
+            <a:ext cx="73152" cy="987552"/>
+          </a:xfrm>
+          <a:prstGeom prst="roundRect">
+            <a:avLst/>
+          </a:prstGeom>
+          <a:solidFill>
+            <a:srgbClr val="D7AA4B"/>
+          </a:solidFill>
+          <a:ln>
+            <a:noFill/>
+          </a:ln>
+        </p:spPr>
+        <p:style>
+          <a:lnRef idx="1">
+            <a:schemeClr val="accent1"/>
+          </a:lnRef>
+          <a:fillRef idx="3">
+            <a:schemeClr val="accent1"/>
+          </a:fillRef>
+          <a:effectRef idx="2">
+            <a:schemeClr val="accent1"/>
+          </a:effectRef>
+          <a:fontRef idx="minor">
+            <a:schemeClr val="lt1"/>
+          </a:fontRef>
+        </p:style>
+        <p:txBody>
+          <a:bodyPr rtlCol="0" anchor="ctr"/>
+          <a:lstStyle/>
+          <a:p>
+            <a:pPr algn="ctr"/>
+          </a:p>
+        </p:txBody>
+      </p:sp>
+      <p:sp>
+        <p:nvSpPr>
+          <p:cNvPr id="19" name="TextBox 18"/>
+          <p:cNvSpPr txBox="1"/>
+          <p:nvPr/>
+        </p:nvSpPr>
+        <p:spPr>
+          <a:xfrm>
+            <a:off x="1005840" y="3273552"/>
+            <a:ext cx="2057400" cy="210312"/>
+          </a:xfrm>
+          <a:prstGeom prst="rect">
+            <a:avLst/>
+          </a:prstGeom>
+          <a:noFill/>
+        </p:spPr>
+        <p:txBody>
+          <a:bodyPr wrap="square" lIns="0" rIns="0" tIns="0" bIns="0">
+            <a:spAutoFit/>
+          </a:bodyPr>
+          <a:lstStyle/>
+          <a:p>
+            <a:pPr algn="l"/>
+            <a:r>
+              <a:rPr sz="1400" b="1">
+                <a:solidFill>
+                  <a:srgbClr val="071B43"/>
+                </a:solidFill>
+                <a:latin typeface="Arial Unicode MS"/>
+                <a:ea typeface="Arial Unicode MS"/>
+                <a:cs typeface="Arial Unicode MS"/>
+              </a:rPr>
+              <a:t>数据边界</a:t>
+            </a:r>
+          </a:p>
+        </p:txBody>
+      </p:sp>
+      <p:sp>
+        <p:nvSpPr>
+          <p:cNvPr id="20" name="TextBox 19"/>
+          <p:cNvSpPr txBox="1"/>
+          <p:nvPr/>
+        </p:nvSpPr>
+        <p:spPr>
+          <a:xfrm>
+            <a:off x="1005840" y="3584448"/>
+            <a:ext cx="2057400" cy="365760"/>
+          </a:xfrm>
+          <a:prstGeom prst="rect">
+            <a:avLst/>
+          </a:prstGeom>
+          <a:noFill/>
+        </p:spPr>
+        <p:txBody>
+          <a:bodyPr wrap="square" lIns="0" rIns="0" tIns="0" bIns="0">
+            <a:spAutoFit/>
+          </a:bodyPr>
+          <a:lstStyle/>
+          <a:p>
+            <a:pPr algn="l"/>
+            <a:r>
+              <a:rPr sz="1000" b="0">
+                <a:solidFill>
+                  <a:srgbClr val="68748B"/>
+                </a:solidFill>
+                <a:latin typeface="Arial Unicode MS"/>
+                <a:ea typeface="Arial Unicode MS"/>
+                <a:cs typeface="Arial Unicode MS"/>
+              </a:rPr>
+              <a:t>用户、业务数据和审计日志可按客户安全域部署与管理</a:t>
+            </a:r>
+          </a:p>
+        </p:txBody>
+      </p:sp>
+      <p:sp>
+        <p:nvSpPr>
+          <p:cNvPr id="21" name="Rounded Rectangle 20"/>
+          <p:cNvSpPr/>
+          <p:nvPr/>
+        </p:nvSpPr>
+        <p:spPr>
+          <a:xfrm>
+            <a:off x="3749039" y="3108960"/>
+            <a:ext cx="2560320" cy="987552"/>
+          </a:xfrm>
+          <a:prstGeom prst="roundRect">
+            <a:avLst/>
+          </a:prstGeom>
+          <a:solidFill>
+            <a:srgbClr val="FFFFFF"/>
+          </a:solidFill>
+          <a:ln w="8890">
+            <a:solidFill>
+              <a:srgbClr val="E0E7F1"/>
+            </a:solidFill>
+          </a:ln>
+        </p:spPr>
+        <p:style>
+          <a:lnRef idx="1">
+            <a:schemeClr val="accent1"/>
+          </a:lnRef>
+          <a:fillRef idx="3">
+            <a:schemeClr val="accent1"/>
+          </a:fillRef>
+          <a:effectRef idx="2">
+            <a:schemeClr val="accent1"/>
+          </a:effectRef>
+          <a:fontRef idx="minor">
+            <a:schemeClr val="lt1"/>
+          </a:fontRef>
+        </p:style>
+        <p:txBody>
+          <a:bodyPr rtlCol="0" anchor="ctr"/>
+          <a:lstStyle/>
+          <a:p>
+            <a:pPr algn="ctr"/>
+          </a:p>
+        </p:txBody>
+      </p:sp>
+      <p:sp>
+        <p:nvSpPr>
+          <p:cNvPr id="22" name="Rounded Rectangle 21"/>
+          <p:cNvSpPr/>
+          <p:nvPr/>
+        </p:nvSpPr>
+        <p:spPr>
+          <a:xfrm>
+            <a:off x="3749039" y="3108960"/>
+            <a:ext cx="73152" cy="987552"/>
+          </a:xfrm>
+          <a:prstGeom prst="roundRect">
+            <a:avLst/>
+          </a:prstGeom>
+          <a:solidFill>
+            <a:srgbClr val="BE4E5B"/>
+          </a:solidFill>
+          <a:ln>
+            <a:noFill/>
+          </a:ln>
+        </p:spPr>
+        <p:style>
+          <a:lnRef idx="1">
+            <a:schemeClr val="accent1"/>
+          </a:lnRef>
+          <a:fillRef idx="3">
+            <a:schemeClr val="accent1"/>
+          </a:fillRef>
+          <a:effectRef idx="2">
+            <a:schemeClr val="accent1"/>
+          </a:effectRef>
+          <a:fontRef idx="minor">
+            <a:schemeClr val="lt1"/>
+          </a:fontRef>
+        </p:style>
+        <p:txBody>
+          <a:bodyPr rtlCol="0" anchor="ctr"/>
+          <a:lstStyle/>
+          <a:p>
+            <a:pPr algn="ctr"/>
+          </a:p>
+        </p:txBody>
+      </p:sp>
+      <p:sp>
+        <p:nvSpPr>
+          <p:cNvPr id="23" name="TextBox 22"/>
+          <p:cNvSpPr txBox="1"/>
+          <p:nvPr/>
+        </p:nvSpPr>
+        <p:spPr>
+          <a:xfrm>
+            <a:off x="3977639" y="3273552"/>
+            <a:ext cx="2057400" cy="210312"/>
+          </a:xfrm>
+          <a:prstGeom prst="rect">
+            <a:avLst/>
+          </a:prstGeom>
+          <a:noFill/>
+        </p:spPr>
+        <p:txBody>
+          <a:bodyPr wrap="square" lIns="0" rIns="0" tIns="0" bIns="0">
+            <a:spAutoFit/>
+          </a:bodyPr>
+          <a:lstStyle/>
+          <a:p>
+            <a:pPr algn="l"/>
+            <a:r>
+              <a:rPr sz="1400" b="1">
+                <a:solidFill>
+                  <a:srgbClr val="071B43"/>
+                </a:solidFill>
+                <a:latin typeface="Arial Unicode MS"/>
+                <a:ea typeface="Arial Unicode MS"/>
+                <a:cs typeface="Arial Unicode MS"/>
+              </a:rPr>
+              <a:t>部署方式</a:t>
+            </a:r>
+          </a:p>
+        </p:txBody>
+      </p:sp>
+      <p:sp>
+        <p:nvSpPr>
+          <p:cNvPr id="24" name="TextBox 23"/>
+          <p:cNvSpPr txBox="1"/>
+          <p:nvPr/>
+        </p:nvSpPr>
+        <p:spPr>
+          <a:xfrm>
+            <a:off x="3977639" y="3584448"/>
+            <a:ext cx="2057400" cy="365760"/>
+          </a:xfrm>
+          <a:prstGeom prst="rect">
+            <a:avLst/>
+          </a:prstGeom>
+          <a:noFill/>
+        </p:spPr>
+        <p:txBody>
+          <a:bodyPr wrap="square" lIns="0" rIns="0" tIns="0" bIns="0">
+            <a:spAutoFit/>
+          </a:bodyPr>
+          <a:lstStyle/>
+          <a:p>
+            <a:pPr algn="l"/>
+            <a:r>
+              <a:rPr sz="1000" b="0">
+                <a:solidFill>
+                  <a:srgbClr val="68748B"/>
+                </a:solidFill>
+                <a:latin typeface="Arial Unicode MS"/>
+                <a:ea typeface="Arial Unicode MS"/>
+                <a:cs typeface="Arial Unicode MS"/>
+              </a:rPr>
+              <a:t>支持部分私有化部署；按客户安全边界组合部署，不等同于全量私有化</a:t>
+            </a:r>
+          </a:p>
+        </p:txBody>
+      </p:sp>
+      <p:sp>
+        <p:nvSpPr>
+          <p:cNvPr id="25" name="Rounded Rectangle 24"/>
+          <p:cNvSpPr/>
+          <p:nvPr/>
+        </p:nvSpPr>
+        <p:spPr>
+          <a:xfrm>
+            <a:off x="6812280" y="1691640"/>
+            <a:ext cx="3886200" cy="4160520"/>
+          </a:xfrm>
+          <a:prstGeom prst="roundRect">
+            <a:avLst/>
+          </a:prstGeom>
+          <a:solidFill>
+            <a:srgbClr val="071B43"/>
+          </a:solidFill>
+          <a:ln>
+            <a:noFill/>
+          </a:ln>
+        </p:spPr>
+        <p:style>
+          <a:lnRef idx="1">
+            <a:schemeClr val="accent1"/>
+          </a:lnRef>
+          <a:fillRef idx="3">
+            <a:schemeClr val="accent1"/>
+          </a:fillRef>
+          <a:effectRef idx="2">
+            <a:schemeClr val="accent1"/>
+          </a:effectRef>
+          <a:fontRef idx="minor">
+            <a:schemeClr val="lt1"/>
+          </a:fontRef>
+        </p:style>
+        <p:txBody>
+          <a:bodyPr rtlCol="0" anchor="ctr"/>
+          <a:lstStyle/>
+          <a:p>
+            <a:pPr algn="ctr"/>
+          </a:p>
+        </p:txBody>
+      </p:sp>
+      <p:sp>
+        <p:nvSpPr>
+          <p:cNvPr id="26" name="TextBox 25"/>
+          <p:cNvSpPr txBox="1"/>
+          <p:nvPr/>
+        </p:nvSpPr>
+        <p:spPr>
+          <a:xfrm>
+            <a:off x="7223760" y="2011680"/>
+            <a:ext cx="3063240" cy="256032"/>
+          </a:xfrm>
+          <a:prstGeom prst="rect">
+            <a:avLst/>
+          </a:prstGeom>
+          <a:noFill/>
+        </p:spPr>
+        <p:txBody>
+          <a:bodyPr wrap="square" lIns="0" rIns="0" tIns="0" bIns="0">
+            <a:spAutoFit/>
+          </a:bodyPr>
+          <a:lstStyle/>
+          <a:p>
+            <a:pPr algn="ctr"/>
+            <a:r>
+              <a:rPr sz="1800" b="1">
+                <a:solidFill>
+                  <a:srgbClr val="FFFFFF"/>
+                </a:solidFill>
+                <a:latin typeface="Arial Unicode MS"/>
+                <a:ea typeface="Arial Unicode MS"/>
+                <a:cs typeface="Arial Unicode MS"/>
+              </a:rPr>
+              <a:t>按安全边界组合部署</a:t>
+            </a:r>
+          </a:p>
+        </p:txBody>
+      </p:sp>
+      <p:sp>
+        <p:nvSpPr>
+          <p:cNvPr id="27" name="Rounded Rectangle 26"/>
+          <p:cNvSpPr/>
+          <p:nvPr/>
+        </p:nvSpPr>
+        <p:spPr>
+          <a:xfrm>
+            <a:off x="7360920" y="2606040"/>
+            <a:ext cx="2788920" cy="658368"/>
+          </a:xfrm>
+          <a:prstGeom prst="roundRect">
+            <a:avLst/>
+          </a:prstGeom>
+          <a:solidFill>
+            <a:srgbClr val="1B4289"/>
+          </a:solidFill>
+          <a:ln>
+            <a:noFill/>
+          </a:ln>
+        </p:spPr>
+        <p:style>
+          <a:lnRef idx="1">
+            <a:schemeClr val="accent1"/>
+          </a:lnRef>
+          <a:fillRef idx="3">
+            <a:schemeClr val="accent1"/>
+          </a:fillRef>
+          <a:effectRef idx="2">
+            <a:schemeClr val="accent1"/>
+          </a:effectRef>
+          <a:fontRef idx="minor">
+            <a:schemeClr val="lt1"/>
+          </a:fontRef>
+        </p:style>
+        <p:txBody>
+          <a:bodyPr rtlCol="0" anchor="ctr"/>
+          <a:lstStyle/>
+          <a:p>
+            <a:pPr algn="ctr"/>
+          </a:p>
+        </p:txBody>
+      </p:sp>
+      <p:sp>
+        <p:nvSpPr>
+          <p:cNvPr id="28" name="TextBox 27"/>
+          <p:cNvSpPr txBox="1"/>
+          <p:nvPr/>
+        </p:nvSpPr>
+        <p:spPr>
+          <a:xfrm>
+            <a:off x="7571231" y="2788920"/>
+            <a:ext cx="2377440" cy="182880"/>
+          </a:xfrm>
+          <a:prstGeom prst="rect">
+            <a:avLst/>
+          </a:prstGeom>
+          <a:noFill/>
+        </p:spPr>
+        <p:txBody>
+          <a:bodyPr wrap="square" lIns="0" rIns="0" tIns="0" bIns="0">
+            <a:spAutoFit/>
+          </a:bodyPr>
+          <a:lstStyle/>
+          <a:p>
+            <a:pPr algn="ctr"/>
+            <a:r>
+              <a:rPr sz="1300" b="1">
+                <a:solidFill>
+                  <a:srgbClr val="FFFFFF"/>
+                </a:solidFill>
+                <a:latin typeface="Arial Unicode MS"/>
+                <a:ea typeface="Arial Unicode MS"/>
+                <a:cs typeface="Arial Unicode MS"/>
+              </a:rPr>
+              <a:t>客户侧安全域</a:t>
+            </a:r>
+          </a:p>
+        </p:txBody>
+      </p:sp>
+      <p:sp>
+        <p:nvSpPr>
+          <p:cNvPr id="29" name="TextBox 28"/>
+          <p:cNvSpPr txBox="1"/>
+          <p:nvPr/>
+        </p:nvSpPr>
+        <p:spPr>
+          <a:xfrm>
+            <a:off x="7571231" y="3054096"/>
+            <a:ext cx="2377440" cy="164592"/>
+          </a:xfrm>
+          <a:prstGeom prst="rect">
+            <a:avLst/>
+          </a:prstGeom>
+          <a:noFill/>
+        </p:spPr>
+        <p:txBody>
+          <a:bodyPr wrap="square" lIns="0" rIns="0" tIns="0" bIns="0">
+            <a:spAutoFit/>
+          </a:bodyPr>
+          <a:lstStyle/>
+          <a:p>
+            <a:pPr algn="ctr"/>
+            <a:r>
+              <a:rPr sz="900" b="0">
+                <a:solidFill>
+                  <a:srgbClr val="BED3F0"/>
+                </a:solidFill>
+                <a:latin typeface="Arial Unicode MS"/>
+                <a:ea typeface="Arial Unicode MS"/>
+                <a:cs typeface="Arial Unicode MS"/>
+              </a:rPr>
+              <a:t>用户 / 业务数据 / 审计日志</a:t>
+            </a:r>
+          </a:p>
+        </p:txBody>
+      </p:sp>
+      <p:sp>
+        <p:nvSpPr>
+          <p:cNvPr id="30" name="TextBox 29"/>
+          <p:cNvSpPr txBox="1"/>
+          <p:nvPr/>
+        </p:nvSpPr>
+        <p:spPr>
+          <a:xfrm>
+            <a:off x="8577072" y="3456432"/>
+            <a:ext cx="228600" cy="228600"/>
+          </a:xfrm>
+          <a:prstGeom prst="rect">
+            <a:avLst/>
+          </a:prstGeom>
+          <a:noFill/>
+        </p:spPr>
+        <p:txBody>
+          <a:bodyPr wrap="square" lIns="0" rIns="0" tIns="0" bIns="0">
+            <a:spAutoFit/>
+          </a:bodyPr>
+          <a:lstStyle/>
+          <a:p>
+            <a:pPr algn="ctr"/>
+            <a:r>
+              <a:rPr sz="1700" b="1">
+                <a:solidFill>
+                  <a:srgbClr val="D7AA4B"/>
+                </a:solidFill>
+                <a:latin typeface="Arial Unicode MS"/>
+                <a:ea typeface="Arial Unicode MS"/>
+                <a:cs typeface="Arial Unicode MS"/>
+              </a:rPr>
+              <a:t>+</a:t>
+            </a:r>
+          </a:p>
+        </p:txBody>
+      </p:sp>
+      <p:sp>
+        <p:nvSpPr>
+          <p:cNvPr id="31" name="Rounded Rectangle 30"/>
+          <p:cNvSpPr/>
+          <p:nvPr/>
+        </p:nvSpPr>
+        <p:spPr>
+          <a:xfrm>
+            <a:off x="7360920" y="3858768"/>
+            <a:ext cx="2788920" cy="658368"/>
+          </a:xfrm>
+          <a:prstGeom prst="roundRect">
+            <a:avLst/>
+          </a:prstGeom>
+          <a:solidFill>
+            <a:srgbClr val="1E746F"/>
+          </a:solidFill>
+          <a:ln>
+            <a:noFill/>
+          </a:ln>
+        </p:spPr>
+        <p:style>
+          <a:lnRef idx="1">
+            <a:schemeClr val="accent1"/>
+          </a:lnRef>
+          <a:fillRef idx="3">
+            <a:schemeClr val="accent1"/>
+          </a:fillRef>
+          <a:effectRef idx="2">
+            <a:schemeClr val="accent1"/>
+          </a:effectRef>
+          <a:fontRef idx="minor">
+            <a:schemeClr val="lt1"/>
+          </a:fontRef>
+        </p:style>
+        <p:txBody>
+          <a:bodyPr rtlCol="0" anchor="ctr"/>
+          <a:lstStyle/>
+          <a:p>
+            <a:pPr algn="ctr"/>
+          </a:p>
+        </p:txBody>
+      </p:sp>
+      <p:sp>
+        <p:nvSpPr>
+          <p:cNvPr id="32" name="TextBox 31"/>
+          <p:cNvSpPr txBox="1"/>
+          <p:nvPr/>
+        </p:nvSpPr>
+        <p:spPr>
+          <a:xfrm>
+            <a:off x="7571231" y="4041648"/>
+            <a:ext cx="2377440" cy="182880"/>
+          </a:xfrm>
+          <a:prstGeom prst="rect">
+            <a:avLst/>
+          </a:prstGeom>
+          <a:noFill/>
+        </p:spPr>
+        <p:txBody>
+          <a:bodyPr wrap="square" lIns="0" rIns="0" tIns="0" bIns="0">
+            <a:spAutoFit/>
+          </a:bodyPr>
+          <a:lstStyle/>
+          <a:p>
+            <a:pPr algn="ctr"/>
+            <a:r>
+              <a:rPr sz="1300" b="1">
+                <a:solidFill>
+                  <a:srgbClr val="FFFFFF"/>
+                </a:solidFill>
+                <a:latin typeface="Arial Unicode MS"/>
+                <a:ea typeface="Arial Unicode MS"/>
+                <a:cs typeface="Arial Unicode MS"/>
+              </a:rPr>
+              <a:t>平台侧可选能力</a:t>
+            </a:r>
+          </a:p>
+        </p:txBody>
+      </p:sp>
+      <p:sp>
+        <p:nvSpPr>
+          <p:cNvPr id="33" name="TextBox 32"/>
+          <p:cNvSpPr txBox="1"/>
+          <p:nvPr/>
+        </p:nvSpPr>
+        <p:spPr>
+          <a:xfrm>
+            <a:off x="7571231" y="4306824"/>
+            <a:ext cx="2377440" cy="164592"/>
+          </a:xfrm>
+          <a:prstGeom prst="rect">
+            <a:avLst/>
+          </a:prstGeom>
+          <a:noFill/>
+        </p:spPr>
+        <p:txBody>
+          <a:bodyPr wrap="square" lIns="0" rIns="0" tIns="0" bIns="0">
+            <a:spAutoFit/>
+          </a:bodyPr>
+          <a:lstStyle/>
+          <a:p>
+            <a:pPr algn="ctr"/>
+            <a:r>
+              <a:rPr sz="900" b="0">
+                <a:solidFill>
+                  <a:srgbClr val="C3EBE2"/>
+                </a:solidFill>
+                <a:latin typeface="Arial Unicode MS"/>
+                <a:ea typeface="Arial Unicode MS"/>
+                <a:cs typeface="Arial Unicode MS"/>
+              </a:rPr>
+              <a:t>内容运营 / 消息 / 直播 / 版本服务</a:t>
+            </a:r>
+          </a:p>
+        </p:txBody>
+      </p:sp>
+      <p:sp>
+        <p:nvSpPr>
+          <p:cNvPr id="34" name="TextBox 33"/>
+          <p:cNvSpPr txBox="1"/>
+          <p:nvPr/>
+        </p:nvSpPr>
+        <p:spPr>
+          <a:xfrm>
+            <a:off x="7114032" y="5074920"/>
+            <a:ext cx="3246120" cy="411480"/>
+          </a:xfrm>
+          <a:prstGeom prst="rect">
+            <a:avLst/>
+          </a:prstGeom>
+          <a:noFill/>
+        </p:spPr>
+        <p:txBody>
+          <a:bodyPr wrap="square" lIns="0" rIns="0" tIns="0" bIns="0">
+            <a:spAutoFit/>
+          </a:bodyPr>
+          <a:lstStyle/>
+          <a:p>
+            <a:pPr algn="ctr"/>
+            <a:r>
+              <a:rPr sz="1000" b="0">
+                <a:solidFill>
+                  <a:srgbClr val="BED3F0"/>
+                </a:solidFill>
+                <a:latin typeface="Arial Unicode MS"/>
+                <a:ea typeface="Arial Unicode MS"/>
+                <a:cs typeface="Arial Unicode MS"/>
+              </a:rPr>
+              <a:t>部署组合需结合客户主体、数据分类分级与法务/安全评审确认。</a:t>
+            </a:r>
+          </a:p>
+        </p:txBody>
+      </p:sp>
+    </p:spTree>
+  </p:cSld>
+  <p:clrMapOvr>
+    <a:masterClrMapping/>
+  </p:clrMapOvr>
+</p:sld>
+</file>
+
+<file path=ppt/slides/slide16.xml><?xml version="1.0" encoding="utf-8"?>
 <p:sld xmlns:a="http://schemas.openxmlformats.org/drawingml/2006/main" xmlns:p="http://schemas.openxmlformats.org/presentationml/2006/main" xmlns:r="http://schemas.openxmlformats.org/officeDocument/2006/relationships">
   <p:cSld>
     <p:spTree>

</xml_diff>

<commit_message>
feat: connect circle interactions with IM
</commit_message>
<xml_diff>
--- a/金融客户定制App产品方案-演示版.pptx
+++ b/金融客户定制App产品方案-演示版.pptx
@@ -19357,22 +19357,22 @@
         <p:spPr>
           <a:xfrm>
             <a:off x="6309360" y="1371600"/>
-            <a:ext cx="4846320" cy="320040"/>
-          </a:xfrm>
-          <a:prstGeom prst="rect">
-            <a:avLst/>
-          </a:prstGeom>
-          <a:noFill/>
-        </p:spPr>
-        <p:txBody>
-          <a:bodyPr wrap="square" lIns="0" rIns="0" tIns="0" bIns="0">
-            <a:spAutoFit/>
-          </a:bodyPr>
-          <a:lstStyle/>
-          <a:p>
-            <a:pPr algn="l"/>
-            <a:r>
-              <a:rPr sz="1600" b="1">
+            <a:ext cx="4846320" cy="502920"/>
+          </a:xfrm>
+          <a:prstGeom prst="rect">
+            <a:avLst/>
+          </a:prstGeom>
+          <a:noFill/>
+        </p:spPr>
+        <p:txBody>
+          <a:bodyPr wrap="square" lIns="0" rIns="0" tIns="0" bIns="0">
+            <a:spAutoFit/>
+          </a:bodyPr>
+          <a:lstStyle/>
+          <a:p>
+            <a:pPr algn="l"/>
+            <a:r>
+              <a:rPr sz="1500" b="1">
                 <a:solidFill>
                   <a:srgbClr val="071B43"/>
                 </a:solidFill>
@@ -19731,7 +19731,7 @@
                 <a:ea typeface="Arial Unicode MS"/>
                 <a:cs typeface="Arial Unicode MS"/>
               </a:rPr>
-              <a:t>圈主置顶、评论互动、话题讨论与成员活跃</a:t>
+              <a:t>圈主置顶、评论互动、IM 群聊与成员活跃</a:t>
             </a:r>
           </a:p>
         </p:txBody>
@@ -19848,7 +19848,7 @@
                 <a:ea typeface="Arial Unicode MS"/>
                 <a:cs typeface="Arial Unicode MS"/>
               </a:rPr>
-              <a:t>课程、直播、会员和投顾服务都能回流到圈子</a:t>
+              <a:t>课程、直播、会员、顾问单聊和人工转接都能回流到圈子</a:t>
             </a:r>
           </a:p>
         </p:txBody>
@@ -20367,7 +20367,7 @@
                 <a:ea typeface="Arial Unicode MS"/>
                 <a:cs typeface="Arial Unicode MS"/>
               </a:rPr>
-              <a:t>点赞、评论、回复、收藏和关注</a:t>
+              <a:t>评论回复、IM 群聊、顾问单聊与人工转接</a:t>
             </a:r>
           </a:p>
         </p:txBody>

</xml_diff>

<commit_message>
feat: rename circle IM as text live room
</commit_message>
<xml_diff>
--- a/金融客户定制App产品方案-演示版.pptx
+++ b/金融客户定制App产品方案-演示版.pptx
@@ -3378,43 +3378,6 @@
         </p:nvSpPr>
         <p:spPr>
           <a:xfrm>
-            <a:off x="749808" y="6080760"/>
-            <a:ext cx="3657600" cy="228600"/>
-          </a:xfrm>
-          <a:prstGeom prst="rect">
-            <a:avLst/>
-          </a:prstGeom>
-          <a:noFill/>
-        </p:spPr>
-        <p:txBody>
-          <a:bodyPr wrap="square" lIns="0" rIns="0" tIns="0" bIns="0">
-            <a:spAutoFit/>
-          </a:bodyPr>
-          <a:lstStyle/>
-          <a:p>
-            <a:pPr algn="l"/>
-            <a:r>
-              <a:rPr sz="1000" b="0">
-                <a:solidFill>
-                  <a:srgbClr val="B0C6E3"/>
-                </a:solidFill>
-                <a:latin typeface="Arial Unicode MS"/>
-                <a:ea typeface="Arial Unicode MS"/>
-                <a:cs typeface="Arial Unicode MS"/>
-              </a:rPr>
-              <a:t>产品方案稿  ·  2026</a:t>
-            </a:r>
-          </a:p>
-        </p:txBody>
-      </p:sp>
-      <p:sp>
-        <p:nvSpPr>
-          <p:cNvPr id="10" name="TextBox 9"/>
-          <p:cNvSpPr txBox="1"/>
-          <p:nvPr/>
-        </p:nvSpPr>
-        <p:spPr>
-          <a:xfrm>
             <a:off x="640080" y="6519672"/>
             <a:ext cx="1828800" cy="164592"/>
           </a:xfrm>
@@ -4975,7 +4938,7 @@
                 <a:ea typeface="Arial Unicode MS"/>
                 <a:cs typeface="Arial Unicode MS"/>
               </a:rPr>
-              <a:t>圈子与群聊</a:t>
+              <a:t>圈子与文字直播间</a:t>
             </a:r>
           </a:p>
         </p:txBody>
@@ -5012,7 +4975,7 @@
                 <a:ea typeface="Arial Unicode MS"/>
                 <a:cs typeface="Arial Unicode MS"/>
               </a:rPr>
-              <a:t>课程群、会员群、直播讨论和主题群</a:t>
+              <a:t>课程群、会员群、实时文字互动和主题群</a:t>
             </a:r>
           </a:p>
         </p:txBody>
@@ -5211,7 +5174,7 @@
                 <a:ea typeface="Arial Unicode MS"/>
                 <a:cs typeface="Arial Unicode MS"/>
               </a:rPr>
-              <a:t>可选供应商（示意）</a:t>
+              <a:t>IM 接入方案（示意）</a:t>
             </a:r>
           </a:p>
         </p:txBody>
@@ -5535,7 +5498,7 @@
                 <a:ea typeface="Arial Unicode MS"/>
                 <a:cs typeface="Arial Unicode MS"/>
               </a:rPr>
-              <a:t>网易云信</a:t>
+              <a:t>其他 IM 厂商</a:t>
             </a:r>
           </a:p>
         </p:txBody>
@@ -5572,7 +5535,7 @@
                 <a:ea typeface="Arial Unicode MS"/>
                 <a:cs typeface="Arial Unicode MS"/>
               </a:rPr>
-              <a:t>音视频与 IM 组合</a:t>
+              <a:t>可按项目接入</a:t>
             </a:r>
           </a:p>
         </p:txBody>
@@ -5609,7 +5572,7 @@
                 <a:ea typeface="Arial Unicode MS"/>
                 <a:cs typeface="Arial Unicode MS"/>
               </a:rPr>
-              <a:t>直播互动、群聊、内容服务</a:t>
+              <a:t>结合客户现有技术栈、账号体系和部署要求</a:t>
             </a:r>
           </a:p>
         </p:txBody>
@@ -5734,7 +5697,7 @@
                 <a:ea typeface="Arial Unicode MS"/>
                 <a:cs typeface="Arial Unicode MS"/>
               </a:rPr>
-              <a:t>融云</a:t>
+              <a:t>选型原则</a:t>
             </a:r>
           </a:p>
         </p:txBody>
@@ -5771,7 +5734,7 @@
                 <a:ea typeface="Arial Unicode MS"/>
                 <a:cs typeface="Arial Unicode MS"/>
               </a:rPr>
-              <a:t>IM 能力组件化接入</a:t>
+              <a:t>以客户安全与合规边界为准</a:t>
             </a:r>
           </a:p>
         </p:txBody>
@@ -5808,412 +5771,14 @@
                 <a:ea typeface="Arial Unicode MS"/>
                 <a:cs typeface="Arial Unicode MS"/>
               </a:rPr>
-              <a:t>单聊、群聊、客服与会话</a:t>
-            </a:r>
-          </a:p>
-        </p:txBody>
-      </p:sp>
-      <p:sp>
-        <p:nvSpPr>
-          <p:cNvPr id="37" name="Rounded Rectangle 36"/>
-          <p:cNvSpPr/>
-          <p:nvPr/>
-        </p:nvSpPr>
-        <p:spPr>
-          <a:xfrm>
-            <a:off x="777240" y="5020056"/>
-            <a:ext cx="10561320" cy="329184"/>
-          </a:xfrm>
-          <a:prstGeom prst="roundRect">
-            <a:avLst/>
-          </a:prstGeom>
-          <a:solidFill>
-            <a:srgbClr val="FFFFFF"/>
-          </a:solidFill>
-          <a:ln w="8890">
-            <a:solidFill>
-              <a:srgbClr val="E0E7F1"/>
-            </a:solidFill>
-          </a:ln>
-        </p:spPr>
-        <p:style>
-          <a:lnRef idx="1">
-            <a:schemeClr val="accent1"/>
-          </a:lnRef>
-          <a:fillRef idx="3">
-            <a:schemeClr val="accent1"/>
-          </a:fillRef>
-          <a:effectRef idx="2">
-            <a:schemeClr val="accent1"/>
-          </a:effectRef>
-          <a:fontRef idx="minor">
-            <a:schemeClr val="lt1"/>
-          </a:fontRef>
-        </p:style>
-        <p:txBody>
-          <a:bodyPr rtlCol="0" anchor="ctr"/>
-          <a:lstStyle/>
-          <a:p>
-            <a:pPr algn="ctr"/>
-          </a:p>
-        </p:txBody>
-      </p:sp>
-      <p:sp>
-        <p:nvSpPr>
-          <p:cNvPr id="38" name="Rounded Rectangle 37"/>
-          <p:cNvSpPr/>
-          <p:nvPr/>
-        </p:nvSpPr>
-        <p:spPr>
-          <a:xfrm>
-            <a:off x="960120" y="5093208"/>
-            <a:ext cx="109728" cy="182880"/>
-          </a:xfrm>
-          <a:prstGeom prst="roundRect">
-            <a:avLst/>
-          </a:prstGeom>
-          <a:solidFill>
-            <a:srgbClr val="BE4E5B"/>
-          </a:solidFill>
-          <a:ln>
-            <a:noFill/>
-          </a:ln>
-        </p:spPr>
-        <p:style>
-          <a:lnRef idx="1">
-            <a:schemeClr val="accent1"/>
-          </a:lnRef>
-          <a:fillRef idx="3">
-            <a:schemeClr val="accent1"/>
-          </a:fillRef>
-          <a:effectRef idx="2">
-            <a:schemeClr val="accent1"/>
-          </a:effectRef>
-          <a:fontRef idx="minor">
-            <a:schemeClr val="lt1"/>
-          </a:fontRef>
-        </p:style>
-        <p:txBody>
-          <a:bodyPr rtlCol="0" anchor="ctr"/>
-          <a:lstStyle/>
-          <a:p>
-            <a:pPr algn="ctr"/>
-          </a:p>
-        </p:txBody>
-      </p:sp>
-      <p:sp>
-        <p:nvSpPr>
-          <p:cNvPr id="39" name="TextBox 38"/>
-          <p:cNvSpPr txBox="1"/>
-          <p:nvPr/>
-        </p:nvSpPr>
-        <p:spPr>
-          <a:xfrm>
-            <a:off x="1261872" y="5093208"/>
-            <a:ext cx="1325880" cy="146304"/>
-          </a:xfrm>
-          <a:prstGeom prst="rect">
-            <a:avLst/>
-          </a:prstGeom>
-          <a:noFill/>
-        </p:spPr>
-        <p:txBody>
-          <a:bodyPr wrap="square" lIns="0" rIns="0" tIns="0" bIns="0">
-            <a:spAutoFit/>
-          </a:bodyPr>
-          <a:lstStyle/>
-          <a:p>
-            <a:pPr algn="l"/>
-            <a:r>
-              <a:rPr sz="1000" b="1">
-                <a:solidFill>
-                  <a:srgbClr val="071B43"/>
-                </a:solidFill>
-                <a:latin typeface="Arial Unicode MS"/>
-                <a:ea typeface="Arial Unicode MS"/>
-                <a:cs typeface="Arial Unicode MS"/>
-              </a:rPr>
-              <a:t>环信</a:t>
-            </a:r>
-          </a:p>
-        </p:txBody>
-      </p:sp>
-      <p:sp>
-        <p:nvSpPr>
-          <p:cNvPr id="40" name="TextBox 39"/>
-          <p:cNvSpPr txBox="1"/>
-          <p:nvPr/>
-        </p:nvSpPr>
-        <p:spPr>
-          <a:xfrm>
-            <a:off x="2834640" y="5093208"/>
-            <a:ext cx="2651760" cy="146304"/>
-          </a:xfrm>
-          <a:prstGeom prst="rect">
-            <a:avLst/>
-          </a:prstGeom>
-          <a:noFill/>
-        </p:spPr>
-        <p:txBody>
-          <a:bodyPr wrap="square" lIns="0" rIns="0" tIns="0" bIns="0">
-            <a:spAutoFit/>
-          </a:bodyPr>
-          <a:lstStyle/>
-          <a:p>
-            <a:pPr algn="l"/>
-            <a:r>
-              <a:rPr sz="900" b="0">
-                <a:solidFill>
-                  <a:srgbClr val="68748B"/>
-                </a:solidFill>
-                <a:latin typeface="Arial Unicode MS"/>
-                <a:ea typeface="Arial Unicode MS"/>
-                <a:cs typeface="Arial Unicode MS"/>
-              </a:rPr>
-              <a:t>客服与运营场景</a:t>
-            </a:r>
-          </a:p>
-        </p:txBody>
-      </p:sp>
-      <p:sp>
-        <p:nvSpPr>
-          <p:cNvPr id="41" name="TextBox 40"/>
-          <p:cNvSpPr txBox="1"/>
-          <p:nvPr/>
-        </p:nvSpPr>
-        <p:spPr>
-          <a:xfrm>
-            <a:off x="5760720" y="5093208"/>
-            <a:ext cx="4297680" cy="146304"/>
-          </a:xfrm>
-          <a:prstGeom prst="rect">
-            <a:avLst/>
-          </a:prstGeom>
-          <a:noFill/>
-        </p:spPr>
-        <p:txBody>
-          <a:bodyPr wrap="square" lIns="0" rIns="0" tIns="0" bIns="0">
-            <a:spAutoFit/>
-          </a:bodyPr>
-          <a:lstStyle/>
-          <a:p>
-            <a:pPr algn="l"/>
-            <a:r>
-              <a:rPr sz="900" b="0">
-                <a:solidFill>
-                  <a:srgbClr val="68748B"/>
-                </a:solidFill>
-                <a:latin typeface="Arial Unicode MS"/>
-                <a:ea typeface="Arial Unicode MS"/>
-                <a:cs typeface="Arial Unicode MS"/>
-              </a:rPr>
-              <a:t>客户咨询、工单与消息触达</a:t>
-            </a:r>
-          </a:p>
-        </p:txBody>
-      </p:sp>
-      <p:sp>
-        <p:nvSpPr>
-          <p:cNvPr id="42" name="Rounded Rectangle 41"/>
-          <p:cNvSpPr/>
-          <p:nvPr/>
-        </p:nvSpPr>
-        <p:spPr>
-          <a:xfrm>
-            <a:off x="777240" y="5458968"/>
-            <a:ext cx="10561320" cy="329184"/>
-          </a:xfrm>
-          <a:prstGeom prst="roundRect">
-            <a:avLst/>
-          </a:prstGeom>
-          <a:solidFill>
-            <a:srgbClr val="FFFFFF"/>
-          </a:solidFill>
-          <a:ln w="8890">
-            <a:solidFill>
-              <a:srgbClr val="E0E7F1"/>
-            </a:solidFill>
-          </a:ln>
-        </p:spPr>
-        <p:style>
-          <a:lnRef idx="1">
-            <a:schemeClr val="accent1"/>
-          </a:lnRef>
-          <a:fillRef idx="3">
-            <a:schemeClr val="accent1"/>
-          </a:fillRef>
-          <a:effectRef idx="2">
-            <a:schemeClr val="accent1"/>
-          </a:effectRef>
-          <a:fontRef idx="minor">
-            <a:schemeClr val="lt1"/>
-          </a:fontRef>
-        </p:style>
-        <p:txBody>
-          <a:bodyPr rtlCol="0" anchor="ctr"/>
-          <a:lstStyle/>
-          <a:p>
-            <a:pPr algn="ctr"/>
-          </a:p>
-        </p:txBody>
-      </p:sp>
-      <p:sp>
-        <p:nvSpPr>
-          <p:cNvPr id="43" name="Rounded Rectangle 42"/>
-          <p:cNvSpPr/>
-          <p:nvPr/>
-        </p:nvSpPr>
-        <p:spPr>
-          <a:xfrm>
-            <a:off x="960120" y="5532120"/>
-            <a:ext cx="109728" cy="182880"/>
-          </a:xfrm>
-          <a:prstGeom prst="roundRect">
-            <a:avLst/>
-          </a:prstGeom>
-          <a:solidFill>
-            <a:srgbClr val="7B97D2"/>
-          </a:solidFill>
-          <a:ln>
-            <a:noFill/>
-          </a:ln>
-        </p:spPr>
-        <p:style>
-          <a:lnRef idx="1">
-            <a:schemeClr val="accent1"/>
-          </a:lnRef>
-          <a:fillRef idx="3">
-            <a:schemeClr val="accent1"/>
-          </a:fillRef>
-          <a:effectRef idx="2">
-            <a:schemeClr val="accent1"/>
-          </a:effectRef>
-          <a:fontRef idx="minor">
-            <a:schemeClr val="lt1"/>
-          </a:fontRef>
-        </p:style>
-        <p:txBody>
-          <a:bodyPr rtlCol="0" anchor="ctr"/>
-          <a:lstStyle/>
-          <a:p>
-            <a:pPr algn="ctr"/>
-          </a:p>
-        </p:txBody>
-      </p:sp>
-      <p:sp>
-        <p:nvSpPr>
-          <p:cNvPr id="44" name="TextBox 43"/>
-          <p:cNvSpPr txBox="1"/>
-          <p:nvPr/>
-        </p:nvSpPr>
-        <p:spPr>
-          <a:xfrm>
-            <a:off x="1261872" y="5532120"/>
-            <a:ext cx="1325880" cy="146304"/>
-          </a:xfrm>
-          <a:prstGeom prst="rect">
-            <a:avLst/>
-          </a:prstGeom>
-          <a:noFill/>
-        </p:spPr>
-        <p:txBody>
-          <a:bodyPr wrap="square" lIns="0" rIns="0" tIns="0" bIns="0">
-            <a:spAutoFit/>
-          </a:bodyPr>
-          <a:lstStyle/>
-          <a:p>
-            <a:pPr algn="l"/>
-            <a:r>
-              <a:rPr sz="1000" b="1">
-                <a:solidFill>
-                  <a:srgbClr val="071B43"/>
-                </a:solidFill>
-                <a:latin typeface="Arial Unicode MS"/>
-                <a:ea typeface="Arial Unicode MS"/>
-                <a:cs typeface="Arial Unicode MS"/>
-              </a:rPr>
-              <a:t>声网 Chat</a:t>
-            </a:r>
-          </a:p>
-        </p:txBody>
-      </p:sp>
-      <p:sp>
-        <p:nvSpPr>
-          <p:cNvPr id="45" name="TextBox 44"/>
-          <p:cNvSpPr txBox="1"/>
-          <p:nvPr/>
-        </p:nvSpPr>
-        <p:spPr>
-          <a:xfrm>
-            <a:off x="2834640" y="5532120"/>
-            <a:ext cx="2651760" cy="146304"/>
-          </a:xfrm>
-          <a:prstGeom prst="rect">
-            <a:avLst/>
-          </a:prstGeom>
-          <a:noFill/>
-        </p:spPr>
-        <p:txBody>
-          <a:bodyPr wrap="square" lIns="0" rIns="0" tIns="0" bIns="0">
-            <a:spAutoFit/>
-          </a:bodyPr>
-          <a:lstStyle/>
-          <a:p>
-            <a:pPr algn="l"/>
-            <a:r>
-              <a:rPr sz="900" b="0">
-                <a:solidFill>
-                  <a:srgbClr val="68748B"/>
-                </a:solidFill>
-                <a:latin typeface="Arial Unicode MS"/>
-                <a:ea typeface="Arial Unicode MS"/>
-                <a:cs typeface="Arial Unicode MS"/>
-              </a:rPr>
-              <a:t>实时互动场景</a:t>
-            </a:r>
-          </a:p>
-        </p:txBody>
-      </p:sp>
-      <p:sp>
-        <p:nvSpPr>
-          <p:cNvPr id="46" name="TextBox 45"/>
-          <p:cNvSpPr txBox="1"/>
-          <p:nvPr/>
-        </p:nvSpPr>
-        <p:spPr>
-          <a:xfrm>
-            <a:off x="5760720" y="5532120"/>
-            <a:ext cx="4297680" cy="146304"/>
-          </a:xfrm>
-          <a:prstGeom prst="rect">
-            <a:avLst/>
-          </a:prstGeom>
-          <a:noFill/>
-        </p:spPr>
-        <p:txBody>
-          <a:bodyPr wrap="square" lIns="0" rIns="0" tIns="0" bIns="0">
-            <a:spAutoFit/>
-          </a:bodyPr>
-          <a:lstStyle/>
-          <a:p>
-            <a:pPr algn="l"/>
-            <a:r>
-              <a:rPr sz="900" b="0">
-                <a:solidFill>
-                  <a:srgbClr val="68748B"/>
-                </a:solidFill>
-                <a:latin typeface="Arial Unicode MS"/>
-                <a:ea typeface="Arial Unicode MS"/>
-                <a:cs typeface="Arial Unicode MS"/>
-              </a:rPr>
-              <a:t>直播互动、聊天室与多端接入</a:t>
-            </a:r>
-          </a:p>
-        </p:txBody>
-      </p:sp>
-      <p:sp>
-        <p:nvSpPr>
-          <p:cNvPr id="47" name="TextBox 46"/>
+              <a:t>数据边界、消息审计、部署方式、服务连续性</a:t>
+            </a:r>
+          </a:p>
+        </p:txBody>
+      </p:sp>
+      <p:sp>
+        <p:nvSpPr>
+          <p:cNvPr id="37" name="TextBox 36"/>
           <p:cNvSpPr txBox="1"/>
           <p:nvPr/>
         </p:nvSpPr>
@@ -6243,7 +5808,7 @@
                 <a:ea typeface="Arial Unicode MS"/>
                 <a:cs typeface="Arial Unicode MS"/>
               </a:rPr>
-              <a:t>选型需结合客户已有账号体系、数据边界、消息审计、部署方式与合规评审；供应商可按项目实际情况组合。</a:t>
+              <a:t>腾讯云 IM 可作为默认接入方案；其他 IM 厂商可按客户现有技术栈、数据边界与合规评审结果接入。</a:t>
             </a:r>
           </a:p>
         </p:txBody>
@@ -19380,7 +18945,7 @@
                 <a:ea typeface="Arial Unicode MS"/>
                 <a:cs typeface="Arial Unicode MS"/>
               </a:rPr>
-              <a:t>圈子不是简单群聊，而是结构化、可持续运营的内容社区。</a:t>
+              <a:t>圈子承载内容、文字直播间和服务关系。</a:t>
             </a:r>
           </a:p>
         </p:txBody>
@@ -19731,7 +19296,7 @@
                 <a:ea typeface="Arial Unicode MS"/>
                 <a:cs typeface="Arial Unicode MS"/>
               </a:rPr>
-              <a:t>圈主置顶、评论互动、IM 群聊与成员活跃</a:t>
+              <a:t>圈主置顶、评论互动、文字直播间与成员活跃</a:t>
             </a:r>
           </a:p>
         </p:txBody>
@@ -19848,7 +19413,7 @@
                 <a:ea typeface="Arial Unicode MS"/>
                 <a:cs typeface="Arial Unicode MS"/>
               </a:rPr>
-              <a:t>课程、直播、会员、顾问单聊和人工转接都能回流到圈子</a:t>
+              <a:t>课程、直播、会员、顾问答疑和人工转接都能回流到圈子</a:t>
             </a:r>
           </a:p>
         </p:txBody>
@@ -20367,7 +19932,7 @@
                 <a:ea typeface="Arial Unicode MS"/>
                 <a:cs typeface="Arial Unicode MS"/>
               </a:rPr>
-              <a:t>评论回复、IM 群聊、顾问单聊与人工转接</a:t>
+              <a:t>评论回复、文字直播间、顾问答疑与人工转接</a:t>
             </a:r>
           </a:p>
         </p:txBody>
@@ -20690,7 +20255,7 @@
                 <a:ea typeface="Arial Unicode MS"/>
                 <a:cs typeface="Arial Unicode MS"/>
               </a:rPr>
-              <a:t>圈子运营的目标：让用户有内容可看、有关系可互动、有服务可继续。</a:t>
+              <a:t>文字直播间把圈子内容延伸为实时互动和服务承接。</a:t>
             </a:r>
           </a:p>
         </p:txBody>

</xml_diff>